<commit_message>
talk: piso de 28 pt nos slides principais
O data-show da sala fica mal posicionado. Os slides 1 a 8 foram redesenhados
para que nenhum texto fique abaixo de 28 pt (exceto a moldura do evento e os
números dos eixos da figura); as reservas ficam como estavam.

Co-Authored-By: Claude Opus 5.5 <noreply@anthropic.com>
Claude-Session: https://claude.ai/code/session_01DFzhQx16GXrgQs3QusNGF8
</commit_message>
<xml_diff>
--- a/overleaf/talk-latinoware-2026/slides.pptx
+++ b/overleaf/talk-latinoware-2026/slides.pptx
@@ -7204,8 +7204,8 @@
         </p:nvSpPr>
         <p:spPr>
           <a:xfrm>
-            <a:off x="9048750" y="4362450"/>
-            <a:ext cx="8572500" cy="857250"/>
+            <a:off x="9048750" y="4297680"/>
+            <a:ext cx="8572500" cy="1051560"/>
           </a:xfrm>
           <a:prstGeom prst="rect">
             <a:avLst/>
@@ -7222,7 +7222,7 @@
               <a:buNone/>
             </a:pPr>
             <a:r>
-              <a:rPr lang="pt-BR" sz="2500" b="0" i="0" u="none" strike="noStrike" kern="1200" cap="none" spc="0" baseline="0">
+              <a:rPr lang="pt-BR" sz="3000" b="0" i="0" u="none" strike="noStrike" kern="1200" cap="none" spc="0" baseline="0">
                 <a:solidFill>
                   <a:srgbClr val="5B6178"/>
                 </a:solidFill>
@@ -7239,7 +7239,7 @@
               <a:buNone/>
             </a:pPr>
             <a:r>
-              <a:rPr lang="pt-BR" sz="2500" b="0" i="0" u="none" strike="noStrike" kern="1200" cap="none" spc="0" baseline="0">
+              <a:rPr lang="pt-BR" sz="3000" b="0" i="0" u="none" strike="noStrike" kern="1200" cap="none" spc="0" baseline="0">
                 <a:solidFill>
                   <a:srgbClr val="5B6178"/>
                 </a:solidFill>
@@ -7261,8 +7261,8 @@
         </p:nvSpPr>
         <p:spPr>
           <a:xfrm>
-            <a:off x="9553575" y="5753100"/>
-            <a:ext cx="7620000" cy="419100"/>
+            <a:off x="9553575" y="5577840"/>
+            <a:ext cx="7620000" cy="457200"/>
           </a:xfrm>
           <a:prstGeom prst="rect">
             <a:avLst/>
@@ -7279,7 +7279,7 @@
               <a:buNone/>
             </a:pPr>
             <a:r>
-              <a:rPr lang="pt-BR" sz="2500" b="1" i="1" u="none" strike="noStrike" kern="1200" cap="none" spc="0" baseline="0">
+              <a:rPr lang="pt-BR" sz="2800" b="1" i="1" u="none" strike="noStrike" kern="1200" cap="none" spc="0" baseline="0">
                 <a:solidFill>
                   <a:srgbClr val="1B2740"/>
                 </a:solidFill>
@@ -7301,8 +7301,8 @@
         </p:nvSpPr>
         <p:spPr>
           <a:xfrm>
-            <a:off x="9553575" y="6229350"/>
-            <a:ext cx="7620000" cy="800100"/>
+            <a:off x="9553575" y="6080760"/>
+            <a:ext cx="7620000" cy="914400"/>
           </a:xfrm>
           <a:prstGeom prst="rect">
             <a:avLst/>
@@ -7319,7 +7319,7 @@
               <a:buNone/>
             </a:pPr>
             <a:r>
-              <a:rPr lang="pt-BR" sz="2400" b="0" i="0" u="none" strike="noStrike" kern="1200" cap="none" spc="0" baseline="0">
+              <a:rPr lang="pt-BR" sz="2800" b="0" i="0" u="none" strike="noStrike" kern="1200" cap="none" spc="0" baseline="0">
                 <a:solidFill>
                   <a:srgbClr val="1B2740"/>
                 </a:solidFill>
@@ -7336,7 +7336,7 @@
               <a:buNone/>
             </a:pPr>
             <a:r>
-              <a:rPr lang="pt-BR" sz="2400" b="0" i="0" u="none" strike="noStrike" kern="1200" cap="none" spc="0" baseline="0">
+              <a:rPr lang="pt-BR" sz="2800" b="0" i="0" u="none" strike="noStrike" kern="1200" cap="none" spc="0" baseline="0">
                 <a:solidFill>
                   <a:srgbClr val="1B2740"/>
                 </a:solidFill>
@@ -7358,8 +7358,8 @@
         </p:nvSpPr>
         <p:spPr>
           <a:xfrm>
-            <a:off x="9553575" y="7162800"/>
-            <a:ext cx="7620000" cy="666750"/>
+            <a:off x="9553575" y="7178040"/>
+            <a:ext cx="7620000" cy="502920"/>
           </a:xfrm>
           <a:prstGeom prst="rect">
             <a:avLst/>
@@ -7376,7 +7376,7 @@
               <a:buNone/>
             </a:pPr>
             <a:r>
-              <a:rPr lang="pt-BR" sz="2000" b="0" i="0" u="none" strike="noStrike" kern="1200" cap="none" spc="0" baseline="0">
+              <a:rPr lang="pt-BR" sz="2800" b="0" i="0" u="none" strike="noStrike" kern="1200" cap="none" spc="0" baseline="0">
                 <a:solidFill>
                   <a:srgbClr val="5B6178"/>
                 </a:solidFill>
@@ -7385,24 +7385,7 @@
                 <a:cs typeface="Montserrat Medium"/>
                 <a:sym typeface="Montserrat Medium"/>
               </a:rPr>
-              <a:t>Instituto Federal do Espírito Santo (IFES)</a:t>
-            </a:r>
-          </a:p>
-          <a:p>
-            <a:pPr marL="0" indent="0" algn="l">
-              <a:buNone/>
-            </a:pPr>
-            <a:r>
-              <a:rPr lang="pt-BR" sz="2000" b="0" i="0" u="none" strike="noStrike" kern="1200" cap="none" spc="0" baseline="0">
-                <a:solidFill>
-                  <a:srgbClr val="5B6178"/>
-                </a:solidFill>
-                <a:latin typeface="Montserrat Medium"/>
-                <a:ea typeface="Montserrat Medium"/>
-                <a:cs typeface="Montserrat Medium"/>
-                <a:sym typeface="Montserrat Medium"/>
-              </a:rPr>
-              <a:t>Cachoeiro de Itapemirim</a:t>
+              <a:t>Ifes, Cachoeiro de Itapemirim</a:t>
             </a:r>
           </a:p>
         </p:txBody>
@@ -13817,8 +13800,8 @@
         </p:nvSpPr>
         <p:spPr>
           <a:xfrm>
-            <a:off x="1028700" y="2971800"/>
-            <a:ext cx="7886700" cy="5120640"/>
+            <a:off x="1028700" y="2926080"/>
+            <a:ext cx="7886700" cy="5166360"/>
           </a:xfrm>
           <a:prstGeom prst="roundRect">
             <a:avLst>
@@ -13848,8 +13831,8 @@
         </p:nvSpPr>
         <p:spPr>
           <a:xfrm>
-            <a:off x="1485900" y="3291840"/>
-            <a:ext cx="6972300" cy="502920"/>
+            <a:off x="1485900" y="3200400"/>
+            <a:ext cx="6972300" cy="548640"/>
           </a:xfrm>
           <a:prstGeom prst="rect">
             <a:avLst/>
@@ -13866,7 +13849,7 @@
               <a:buNone/>
             </a:pPr>
             <a:r>
-              <a:rPr lang="pt-BR" sz="3000" b="1" i="0" u="none" strike="noStrike" kern="1200" cap="none" spc="0" baseline="0">
+              <a:rPr lang="pt-BR" sz="3400" b="1" i="0" u="none" strike="noStrike" kern="1200" cap="none" spc="0" baseline="0">
                 <a:solidFill>
                   <a:srgbClr val="1B2740"/>
                 </a:solidFill>
@@ -13888,8 +13871,8 @@
         </p:nvSpPr>
         <p:spPr>
           <a:xfrm>
-            <a:off x="1485900" y="3931920"/>
-            <a:ext cx="3657600" cy="320040"/>
+            <a:off x="1485900" y="3886200"/>
+            <a:ext cx="4572000" cy="457200"/>
           </a:xfrm>
           <a:prstGeom prst="rect">
             <a:avLst/>
@@ -13906,7 +13889,7 @@
               <a:buNone/>
             </a:pPr>
             <a:r>
-              <a:rPr lang="pt-BR" sz="1800" b="0" i="0" u="none" strike="noStrike" kern="1200" cap="none" spc="0" baseline="0">
+              <a:rPr lang="pt-BR" sz="2800" b="0" i="0" u="none" strike="noStrike" kern="1200" cap="none" spc="0" baseline="0">
                 <a:solidFill>
                   <a:srgbClr val="5B6178"/>
                 </a:solidFill>
@@ -13929,7 +13912,7 @@
         <p:spPr>
           <a:xfrm>
             <a:off x="1485900" y="6903720"/>
-            <a:ext cx="6195060" cy="0"/>
+            <a:ext cx="5875020" cy="0"/>
           </a:xfrm>
           <a:prstGeom prst="line">
             <a:avLst/>
@@ -13949,13 +13932,13 @@
         </p:nvCxnSpPr>
         <p:spPr>
           <a:xfrm>
-            <a:off x="1485900" y="5669280"/>
-            <a:ext cx="6195060" cy="0"/>
+            <a:off x="1485900" y="5737860"/>
+            <a:ext cx="5875020" cy="0"/>
           </a:xfrm>
           <a:prstGeom prst="line">
             <a:avLst/>
           </a:prstGeom>
-          <a:ln w="19050">
+          <a:ln w="22225">
             <a:solidFill>
               <a:srgbClr val="5B6178"/>
             </a:solidFill>
@@ -13971,8 +13954,8 @@
         </p:nvSpPr>
         <p:spPr>
           <a:xfrm>
-            <a:off x="7790688" y="5504688"/>
-            <a:ext cx="685800" cy="329184"/>
+            <a:off x="7498080" y="5509260"/>
+            <a:ext cx="1005840" cy="457200"/>
           </a:xfrm>
           <a:prstGeom prst="rect">
             <a:avLst/>
@@ -13989,7 +13972,7 @@
               <a:buNone/>
             </a:pPr>
             <a:r>
-              <a:rPr lang="pt-BR" sz="1800" b="1" i="0" u="none" strike="noStrike" kern="1200" cap="none" spc="0" baseline="0">
+              <a:rPr lang="pt-BR" sz="2800" b="1" i="0" u="none" strike="noStrike" kern="1200" cap="none" spc="0" baseline="0">
                 <a:solidFill>
                   <a:srgbClr val="5B6178"/>
                 </a:solidFill>
@@ -14011,8 +13994,8 @@
         </p:nvSpPr>
         <p:spPr>
           <a:xfrm>
-            <a:off x="1758483" y="4533595"/>
-            <a:ext cx="693847" cy="2370125"/>
+            <a:off x="1732651" y="4665269"/>
+            <a:ext cx="681502" cy="2238451"/>
           </a:xfrm>
           <a:prstGeom prst="rect">
             <a:avLst/>
@@ -14040,8 +14023,8 @@
         </p:nvSpPr>
         <p:spPr>
           <a:xfrm>
-            <a:off x="2997495" y="5866790"/>
-            <a:ext cx="693847" cy="1036930"/>
+            <a:off x="2907655" y="5924398"/>
+            <a:ext cx="681502" cy="979322"/>
           </a:xfrm>
           <a:prstGeom prst="rect">
             <a:avLst/>
@@ -14069,8 +14052,8 @@
         </p:nvSpPr>
         <p:spPr>
           <a:xfrm>
-            <a:off x="4236507" y="6212434"/>
-            <a:ext cx="693847" cy="691286"/>
+            <a:off x="4082659" y="6250838"/>
+            <a:ext cx="681502" cy="652882"/>
           </a:xfrm>
           <a:prstGeom prst="rect">
             <a:avLst/>
@@ -14098,8 +14081,8 @@
         </p:nvSpPr>
         <p:spPr>
           <a:xfrm>
-            <a:off x="5475519" y="6014923"/>
-            <a:ext cx="693847" cy="888797"/>
+            <a:off x="5257663" y="6064301"/>
+            <a:ext cx="681502" cy="839419"/>
           </a:xfrm>
           <a:prstGeom prst="rect">
             <a:avLst/>
@@ -14127,8 +14110,8 @@
         </p:nvSpPr>
         <p:spPr>
           <a:xfrm>
-            <a:off x="6714531" y="6508699"/>
-            <a:ext cx="693847" cy="395021"/>
+            <a:off x="6432667" y="6530645"/>
+            <a:ext cx="681502" cy="373075"/>
           </a:xfrm>
           <a:prstGeom prst="rect">
             <a:avLst/>
@@ -14157,7 +14140,7 @@
         <p:spPr>
           <a:xfrm>
             <a:off x="1485900" y="7178040"/>
-            <a:ext cx="6972300" cy="548640"/>
+            <a:ext cx="6972300" cy="594360"/>
           </a:xfrm>
           <a:prstGeom prst="rect">
             <a:avLst/>
@@ -14174,7 +14157,7 @@
               <a:buNone/>
             </a:pPr>
             <a:r>
-              <a:rPr lang="pt-BR" sz="2400" b="0" i="0" u="none" strike="noStrike" kern="1200" cap="none" spc="0" baseline="0">
+              <a:rPr lang="pt-BR" sz="3000" b="0" i="0" u="none" strike="noStrike" kern="1200" cap="none" spc="0" baseline="0">
                 <a:solidFill>
                   <a:srgbClr val="1B2740"/>
                 </a:solidFill>
@@ -14196,8 +14179,8 @@
         </p:nvSpPr>
         <p:spPr>
           <a:xfrm>
-            <a:off x="9372600" y="2971800"/>
-            <a:ext cx="7886700" cy="5120640"/>
+            <a:off x="9372600" y="2926080"/>
+            <a:ext cx="7886700" cy="5166360"/>
           </a:xfrm>
           <a:prstGeom prst="roundRect">
             <a:avLst>
@@ -14227,8 +14210,8 @@
         </p:nvSpPr>
         <p:spPr>
           <a:xfrm>
-            <a:off x="9829800" y="3291840"/>
-            <a:ext cx="6972300" cy="502920"/>
+            <a:off x="9829800" y="3200400"/>
+            <a:ext cx="6972300" cy="548640"/>
           </a:xfrm>
           <a:prstGeom prst="rect">
             <a:avLst/>
@@ -14245,7 +14228,7 @@
               <a:buNone/>
             </a:pPr>
             <a:r>
-              <a:rPr lang="pt-BR" sz="3000" b="1" i="0" u="none" strike="noStrike" kern="1200" cap="none" spc="0" baseline="0">
+              <a:rPr lang="pt-BR" sz="3400" b="1" i="0" u="none" strike="noStrike" kern="1200" cap="none" spc="0" baseline="0">
                 <a:solidFill>
                   <a:srgbClr val="1B2740"/>
                 </a:solidFill>
@@ -14267,8 +14250,8 @@
         </p:nvSpPr>
         <p:spPr>
           <a:xfrm>
-            <a:off x="9829800" y="3931920"/>
-            <a:ext cx="3657600" cy="320040"/>
+            <a:off x="9829800" y="3886200"/>
+            <a:ext cx="4572000" cy="457200"/>
           </a:xfrm>
           <a:prstGeom prst="rect">
             <a:avLst/>
@@ -14285,7 +14268,7 @@
               <a:buNone/>
             </a:pPr>
             <a:r>
-              <a:rPr lang="pt-BR" sz="1800" b="0" i="0" u="none" strike="noStrike" kern="1200" cap="none" spc="0" baseline="0">
+              <a:rPr lang="pt-BR" sz="2800" b="0" i="0" u="none" strike="noStrike" kern="1200" cap="none" spc="0" baseline="0">
                 <a:solidFill>
                   <a:srgbClr val="5B6178"/>
                 </a:solidFill>
@@ -14308,7 +14291,7 @@
         <p:spPr>
           <a:xfrm>
             <a:off x="9829800" y="6903720"/>
-            <a:ext cx="6195060" cy="0"/>
+            <a:ext cx="5875020" cy="0"/>
           </a:xfrm>
           <a:prstGeom prst="line">
             <a:avLst/>
@@ -14328,13 +14311,13 @@
         </p:nvCxnSpPr>
         <p:spPr>
           <a:xfrm>
-            <a:off x="9829800" y="5669280"/>
-            <a:ext cx="6195060" cy="0"/>
+            <a:off x="9829800" y="5737860"/>
+            <a:ext cx="5875020" cy="0"/>
           </a:xfrm>
           <a:prstGeom prst="line">
             <a:avLst/>
           </a:prstGeom>
-          <a:ln w="19050">
+          <a:ln w="22225">
             <a:solidFill>
               <a:srgbClr val="5B6178"/>
             </a:solidFill>
@@ -14350,8 +14333,8 @@
         </p:nvSpPr>
         <p:spPr>
           <a:xfrm>
-            <a:off x="16134588" y="5504688"/>
-            <a:ext cx="685800" cy="329184"/>
+            <a:off x="15841980" y="5509260"/>
+            <a:ext cx="1005840" cy="457200"/>
           </a:xfrm>
           <a:prstGeom prst="rect">
             <a:avLst/>
@@ -14368,7 +14351,7 @@
               <a:buNone/>
             </a:pPr>
             <a:r>
-              <a:rPr lang="pt-BR" sz="1800" b="1" i="0" u="none" strike="noStrike" kern="1200" cap="none" spc="0" baseline="0">
+              <a:rPr lang="pt-BR" sz="2800" b="1" i="0" u="none" strike="noStrike" kern="1200" cap="none" spc="0" baseline="0">
                 <a:solidFill>
                   <a:srgbClr val="5B6178"/>
                 </a:solidFill>
@@ -14390,8 +14373,8 @@
         </p:nvSpPr>
         <p:spPr>
           <a:xfrm>
-            <a:off x="10102383" y="5669280"/>
-            <a:ext cx="693847" cy="1234440"/>
+            <a:off x="10076551" y="5737860"/>
+            <a:ext cx="681502" cy="1165860"/>
           </a:xfrm>
           <a:prstGeom prst="rect">
             <a:avLst/>
@@ -14419,8 +14402,8 @@
         </p:nvSpPr>
         <p:spPr>
           <a:xfrm>
-            <a:off x="11341395" y="5669280"/>
-            <a:ext cx="693847" cy="1234440"/>
+            <a:off x="11251555" y="5737860"/>
+            <a:ext cx="681502" cy="1165860"/>
           </a:xfrm>
           <a:prstGeom prst="rect">
             <a:avLst/>
@@ -14448,8 +14431,8 @@
         </p:nvSpPr>
         <p:spPr>
           <a:xfrm>
-            <a:off x="12580407" y="5669280"/>
-            <a:ext cx="693847" cy="1234440"/>
+            <a:off x="12426559" y="5737860"/>
+            <a:ext cx="681502" cy="1165860"/>
           </a:xfrm>
           <a:prstGeom prst="rect">
             <a:avLst/>
@@ -14477,8 +14460,8 @@
         </p:nvSpPr>
         <p:spPr>
           <a:xfrm>
-            <a:off x="13819419" y="5669280"/>
-            <a:ext cx="693847" cy="1234440"/>
+            <a:off x="13601563" y="5737860"/>
+            <a:ext cx="681502" cy="1165860"/>
           </a:xfrm>
           <a:prstGeom prst="rect">
             <a:avLst/>
@@ -14506,8 +14489,8 @@
         </p:nvSpPr>
         <p:spPr>
           <a:xfrm>
-            <a:off x="15058431" y="5669280"/>
-            <a:ext cx="693847" cy="1234440"/>
+            <a:off x="14776567" y="5737860"/>
+            <a:ext cx="681502" cy="1165860"/>
           </a:xfrm>
           <a:prstGeom prst="rect">
             <a:avLst/>
@@ -14536,7 +14519,7 @@
         <p:spPr>
           <a:xfrm>
             <a:off x="9829800" y="7178040"/>
-            <a:ext cx="6972300" cy="548640"/>
+            <a:ext cx="6972300" cy="594360"/>
           </a:xfrm>
           <a:prstGeom prst="rect">
             <a:avLst/>
@@ -14553,7 +14536,7 @@
               <a:buNone/>
             </a:pPr>
             <a:r>
-              <a:rPr lang="pt-BR" sz="2400" b="0" i="0" u="none" strike="noStrike" kern="1200" cap="none" spc="0" baseline="0">
+              <a:rPr lang="pt-BR" sz="3000" b="0" i="0" u="none" strike="noStrike" kern="1200" cap="none" spc="0" baseline="0">
                 <a:solidFill>
                   <a:srgbClr val="1B2740"/>
                 </a:solidFill>
@@ -14575,8 +14558,8 @@
         </p:nvSpPr>
         <p:spPr>
           <a:xfrm>
-            <a:off x="1028700" y="8458200"/>
-            <a:ext cx="16230600" cy="548640"/>
+            <a:off x="1028700" y="8412480"/>
+            <a:ext cx="16230600" cy="640080"/>
           </a:xfrm>
           <a:prstGeom prst="rect">
             <a:avLst/>
@@ -14593,7 +14576,7 @@
               <a:buNone/>
             </a:pPr>
             <a:r>
-              <a:rPr lang="pt-BR" sz="2800" b="0" i="0" u="none" strike="noStrike" kern="1200" cap="none" spc="0" baseline="0">
+              <a:rPr lang="pt-BR" sz="3200" b="0" i="0" u="none" strike="noStrike" kern="1200" cap="none" spc="0" baseline="0">
                 <a:solidFill>
                   <a:srgbClr val="1B2740"/>
                 </a:solidFill>
@@ -14605,7 +14588,7 @@
               <a:t xml:space="preserve">O desafio: equilibrar </a:t>
             </a:r>
             <a:r>
-              <a:rPr lang="pt-BR" sz="2800" b="1" i="0" u="none" strike="noStrike" kern="1200" cap="none" spc="0" baseline="0">
+              <a:rPr lang="pt-BR" sz="3200" b="1" i="0" u="none" strike="noStrike" kern="1200" cap="none" spc="0" baseline="0">
                 <a:solidFill>
                   <a:srgbClr val="685BC7"/>
                 </a:solidFill>
@@ -17401,7 +17384,7 @@
         <p:spPr>
           <a:xfrm>
             <a:off x="1028700" y="4114800"/>
-            <a:ext cx="3048000" cy="400050"/>
+            <a:ext cx="3048000" cy="457200"/>
           </a:xfrm>
           <a:prstGeom prst="rect">
             <a:avLst/>
@@ -17418,7 +17401,7 @@
               <a:buNone/>
             </a:pPr>
             <a:r>
-              <a:rPr lang="pt-BR" sz="2400" b="0" i="0" u="none" strike="noStrike" kern="1200" cap="none" spc="0" baseline="0">
+              <a:rPr lang="pt-BR" sz="2800" b="0" i="0" u="none" strike="noStrike" kern="1200" cap="none" spc="0" baseline="0">
                 <a:solidFill>
                   <a:srgbClr val="685BC7"/>
                 </a:solidFill>
@@ -17512,7 +17495,7 @@
         <p:spPr>
           <a:xfrm>
             <a:off x="4324350" y="4114800"/>
-            <a:ext cx="3048000" cy="400050"/>
+            <a:ext cx="3048000" cy="457200"/>
           </a:xfrm>
           <a:prstGeom prst="rect">
             <a:avLst/>
@@ -17529,7 +17512,7 @@
               <a:buNone/>
             </a:pPr>
             <a:r>
-              <a:rPr lang="pt-BR" sz="2400" b="0" i="0" u="none" strike="noStrike" kern="1200" cap="none" spc="0" baseline="0">
+              <a:rPr lang="pt-BR" sz="2800" b="0" i="0" u="none" strike="noStrike" kern="1200" cap="none" spc="0" baseline="0">
                 <a:solidFill>
                   <a:srgbClr val="685BC7"/>
                 </a:solidFill>
@@ -17623,7 +17606,7 @@
         <p:spPr>
           <a:xfrm>
             <a:off x="7620000" y="4114800"/>
-            <a:ext cx="3048000" cy="400050"/>
+            <a:ext cx="3048000" cy="457200"/>
           </a:xfrm>
           <a:prstGeom prst="rect">
             <a:avLst/>
@@ -17640,7 +17623,7 @@
               <a:buNone/>
             </a:pPr>
             <a:r>
-              <a:rPr lang="pt-BR" sz="2400" b="0" i="0" u="none" strike="noStrike" kern="1200" cap="none" spc="0" baseline="0">
+              <a:rPr lang="pt-BR" sz="2800" b="0" i="0" u="none" strike="noStrike" kern="1200" cap="none" spc="0" baseline="0">
                 <a:solidFill>
                   <a:srgbClr val="685BC7"/>
                 </a:solidFill>
@@ -17734,7 +17717,7 @@
         <p:spPr>
           <a:xfrm>
             <a:off x="10915650" y="4114800"/>
-            <a:ext cx="3048000" cy="400050"/>
+            <a:ext cx="3048000" cy="457200"/>
           </a:xfrm>
           <a:prstGeom prst="rect">
             <a:avLst/>
@@ -17751,7 +17734,7 @@
               <a:buNone/>
             </a:pPr>
             <a:r>
-              <a:rPr lang="pt-BR" sz="2400" b="0" i="0" u="none" strike="noStrike" kern="1200" cap="none" spc="0" baseline="0">
+              <a:rPr lang="pt-BR" sz="2800" b="0" i="0" u="none" strike="noStrike" kern="1200" cap="none" spc="0" baseline="0">
                 <a:solidFill>
                   <a:srgbClr val="685BC7"/>
                 </a:solidFill>
@@ -17845,7 +17828,7 @@
         <p:spPr>
           <a:xfrm>
             <a:off x="14211300" y="4114800"/>
-            <a:ext cx="3048000" cy="400050"/>
+            <a:ext cx="3048000" cy="457200"/>
           </a:xfrm>
           <a:prstGeom prst="rect">
             <a:avLst/>
@@ -17862,7 +17845,7 @@
               <a:buNone/>
             </a:pPr>
             <a:r>
-              <a:rPr lang="pt-BR" sz="2400" b="0" i="0" u="none" strike="noStrike" kern="1200" cap="none" spc="0" baseline="0">
+              <a:rPr lang="pt-BR" sz="2800" b="0" i="0" u="none" strike="noStrike" kern="1200" cap="none" spc="0" baseline="0">
                 <a:solidFill>
                   <a:srgbClr val="685BC7"/>
                 </a:solidFill>
@@ -17885,7 +17868,7 @@
         <p:spPr>
           <a:xfrm>
             <a:off x="1028700" y="4972050"/>
-            <a:ext cx="16230600" cy="361950"/>
+            <a:ext cx="16230600" cy="457200"/>
           </a:xfrm>
           <a:prstGeom prst="rect">
             <a:avLst/>
@@ -17902,7 +17885,7 @@
               <a:buNone/>
             </a:pPr>
             <a:r>
-              <a:rPr lang="pt-BR" sz="2200" b="0" i="0" u="none" strike="noStrike" kern="1200" cap="none" spc="0" baseline="0">
+              <a:rPr lang="pt-BR" sz="2800" b="0" i="0" u="none" strike="noStrike" kern="1200" cap="none" spc="0" baseline="0">
                 <a:solidFill>
                   <a:srgbClr val="5B6178"/>
                 </a:solidFill>
@@ -17956,7 +17939,7 @@
         <p:spPr>
           <a:xfrm>
             <a:off x="1562100" y="6248400"/>
-            <a:ext cx="15163800" cy="323850"/>
+            <a:ext cx="15163800" cy="411480"/>
           </a:xfrm>
           <a:prstGeom prst="rect">
             <a:avLst/>
@@ -17973,7 +17956,7 @@
               <a:buNone/>
             </a:pPr>
             <a:r>
-              <a:rPr lang="pt-BR" sz="2000" b="1" i="0" u="none" strike="noStrike" kern="1200" cap="none" spc="0" baseline="0">
+              <a:rPr lang="pt-BR" sz="2800" b="1" i="0" u="none" strike="noStrike" kern="1200" cap="none" spc="0" baseline="0">
                 <a:solidFill>
                   <a:srgbClr val="BDB6EC"/>
                 </a:solidFill>
@@ -17995,7 +17978,7 @@
         </p:nvSpPr>
         <p:spPr>
           <a:xfrm>
-            <a:off x="1562100" y="6743700"/>
+            <a:off x="1562100" y="6812280"/>
             <a:ext cx="15163800" cy="1809750"/>
           </a:xfrm>
           <a:prstGeom prst="rect">
@@ -18980,8 +18963,8 @@
         </p:nvSpPr>
         <p:spPr>
           <a:xfrm>
-            <a:off x="1028700" y="3017520"/>
-            <a:ext cx="5120640" cy="329184"/>
+            <a:off x="1028700" y="2926080"/>
+            <a:ext cx="4937760" cy="411480"/>
           </a:xfrm>
           <a:prstGeom prst="rect">
             <a:avLst/>
@@ -18998,7 +18981,7 @@
               <a:buNone/>
             </a:pPr>
             <a:r>
-              <a:rPr lang="pt-BR" sz="2000" b="1" i="0" u="none" strike="noStrike" kern="1200" cap="none" spc="0" baseline="0">
+              <a:rPr lang="pt-BR" sz="2800" b="1" i="0" u="none" strike="noStrike" kern="1200" cap="none" spc="0" baseline="0">
                 <a:solidFill>
                   <a:srgbClr val="685BC7"/>
                 </a:solidFill>
@@ -19021,7 +19004,7 @@
         <p:spPr>
           <a:xfrm>
             <a:off x="1028700" y="3474720"/>
-            <a:ext cx="5120640" cy="4160520"/>
+            <a:ext cx="4937760" cy="4251960"/>
           </a:xfrm>
           <a:prstGeom prst="roundRect">
             <a:avLst>
@@ -19043,37 +19026,16 @@
           </a:p>
         </p:txBody>
       </p:sp>
-      <p:cxnSp>
-        <p:nvCxnSpPr>
-          <p:cNvPr id="104" name="Chão"/>
-          <p:cNvCxnSpPr/>
-          <p:nvPr/>
-        </p:nvCxnSpPr>
-        <p:spPr>
-          <a:xfrm>
-            <a:off x="1348740" y="4709160"/>
-            <a:ext cx="4480560" cy="0"/>
-          </a:xfrm>
-          <a:prstGeom prst="line">
-            <a:avLst/>
-          </a:prstGeom>
-          <a:ln w="28575">
-            <a:solidFill>
-              <a:srgbClr val="C9CCD8"/>
-            </a:solidFill>
-          </a:ln>
-        </p:spPr>
-      </p:cxnSp>
-      <p:sp>
-        <p:nvSpPr>
-          <p:cNvPr id="105" name="Lutador 1"/>
+      <p:sp>
+        <p:nvSpPr>
+          <p:cNvPr id="104" name="Lutador 1"/>
           <p:cNvSpPr/>
           <p:nvPr/>
         </p:nvSpPr>
         <p:spPr>
           <a:xfrm>
-            <a:off x="2263140" y="3840480"/>
-            <a:ext cx="731520" cy="731520"/>
+            <a:off x="2125980" y="3794760"/>
+            <a:ext cx="777240" cy="777240"/>
           </a:xfrm>
           <a:prstGeom prst="ellipse">
             <a:avLst/>
@@ -19095,19 +19057,19 @@
       </p:sp>
       <p:cxnSp>
         <p:nvCxnSpPr>
-          <p:cNvPr id="106" name="Avança 1"/>
+          <p:cNvPr id="105" name="Avança 1"/>
           <p:cNvCxnSpPr/>
           <p:nvPr/>
         </p:nvCxnSpPr>
         <p:spPr>
           <a:xfrm>
-            <a:off x="3086100" y="4206240"/>
+            <a:off x="2994660" y="4183380"/>
             <a:ext cx="457200" cy="0"/>
           </a:xfrm>
           <a:prstGeom prst="line">
             <a:avLst/>
           </a:prstGeom>
-          <a:ln w="47625">
+          <a:ln w="57150">
             <a:solidFill>
               <a:srgbClr val="685BC7"/>
             </a:solidFill>
@@ -19117,14 +19079,14 @@
       </p:cxnSp>
       <p:sp>
         <p:nvSpPr>
-          <p:cNvPr id="107" name="Lutador 2"/>
+          <p:cNvPr id="106" name="Lutador 2"/>
           <p:cNvSpPr/>
           <p:nvPr/>
         </p:nvSpPr>
         <p:spPr>
           <a:xfrm>
-            <a:off x="4183380" y="3840480"/>
-            <a:ext cx="731520" cy="731520"/>
+            <a:off x="4091940" y="3794760"/>
+            <a:ext cx="777240" cy="777240"/>
           </a:xfrm>
           <a:prstGeom prst="ellipse">
             <a:avLst/>
@@ -19146,19 +19108,19 @@
       </p:sp>
       <p:cxnSp>
         <p:nvCxnSpPr>
-          <p:cNvPr id="108" name="Avança 2"/>
+          <p:cNvPr id="107" name="Avança 2"/>
           <p:cNvCxnSpPr/>
           <p:nvPr/>
         </p:nvCxnSpPr>
         <p:spPr>
           <a:xfrm flipH="1">
-            <a:off x="3634740" y="4206240"/>
+            <a:off x="3543300" y="4183380"/>
             <a:ext cx="457200" cy="0"/>
           </a:xfrm>
           <a:prstGeom prst="line">
             <a:avLst/>
           </a:prstGeom>
-          <a:ln w="47625">
+          <a:ln w="57150">
             <a:solidFill>
               <a:srgbClr val="C8540F"/>
             </a:solidFill>
@@ -19166,47 +19128,37 @@
           </a:ln>
         </p:spPr>
       </p:cxnSp>
-      <p:sp>
-        <p:nvSpPr>
-          <p:cNvPr id="109" name="Intenção AVANÇAR"/>
-          <p:cNvSpPr/>
-          <p:nvPr/>
-        </p:nvSpPr>
-        <p:spPr>
-          <a:xfrm>
-            <a:off x="1298448" y="4983480"/>
-            <a:ext cx="1417320" cy="457200"/>
-          </a:xfrm>
-          <a:prstGeom prst="roundRect">
-            <a:avLst>
-              <a:gd name="adj" fmla="val 50000"/>
-            </a:avLst>
-          </a:prstGeom>
-          <a:solidFill>
-            <a:srgbClr val="1B2740"/>
-          </a:solidFill>
-          <a:ln>
-            <a:noFill/>
+      <p:cxnSp>
+        <p:nvCxnSpPr>
+          <p:cNvPr id="108" name="Chão"/>
+          <p:cNvCxnSpPr/>
+          <p:nvPr/>
+        </p:nvCxnSpPr>
+        <p:spPr>
+          <a:xfrm>
+            <a:off x="1348740" y="4754880"/>
+            <a:ext cx="4297680" cy="0"/>
+          </a:xfrm>
+          <a:prstGeom prst="line">
+            <a:avLst/>
+          </a:prstGeom>
+          <a:ln w="28575">
+            <a:solidFill>
+              <a:srgbClr val="C9CCD8"/>
+            </a:solidFill>
           </a:ln>
         </p:spPr>
-        <p:txBody>
-          <a:bodyPr rtlCol="0" anchor="ctr"/>
-          <a:lstStyle/>
-          <a:p>
-            <a:pPr algn="ctr"/>
-          </a:p>
-        </p:txBody>
-      </p:sp>
-      <p:sp>
-        <p:nvSpPr>
-          <p:cNvPr id="110" name="Texto AVANÇAR"/>
+      </p:cxnSp>
+      <p:sp>
+        <p:nvSpPr>
+          <p:cNvPr id="109" name="Genes"/>
           <p:cNvSpPr txBox="1"/>
           <p:nvPr/>
         </p:nvSpPr>
         <p:spPr>
           <a:xfrm>
-            <a:off x="1298448" y="4983480"/>
-            <a:ext cx="1417320" cy="457200"/>
+            <a:off x="1348740" y="4983480"/>
+            <a:ext cx="1600200" cy="868680"/>
           </a:xfrm>
           <a:prstGeom prst="rect">
             <a:avLst/>
@@ -19219,193 +19171,11 @@
           </a:bodyPr>
           <a:lstStyle/>
           <a:p>
-            <a:pPr marL="0" indent="0" algn="ctr">
-              <a:buNone/>
-            </a:pPr>
-            <a:r>
-              <a:rPr lang="pt-BR" sz="1500" b="1" i="0" u="none" strike="noStrike" kern="1200" cap="none" spc="0" baseline="0">
-                <a:solidFill>
-                  <a:srgbClr val="FFFFFF"/>
-                </a:solidFill>
-                <a:latin typeface="Montserrat Medium"/>
-                <a:ea typeface="Montserrat Medium"/>
-                <a:cs typeface="Montserrat Medium"/>
-                <a:sym typeface="Montserrat Medium"/>
-              </a:rPr>
-              <a:t xml:space="preserve">AVANÇAR</a:t>
-            </a:r>
-          </a:p>
-        </p:txBody>
-      </p:sp>
-      <p:sp>
-        <p:nvSpPr>
-          <p:cNvPr id="111" name="Intenção RECUAR"/>
-          <p:cNvSpPr/>
-          <p:nvPr/>
-        </p:nvSpPr>
-        <p:spPr>
-          <a:xfrm>
-            <a:off x="2880360" y="4983480"/>
-            <a:ext cx="1417320" cy="457200"/>
-          </a:xfrm>
-          <a:prstGeom prst="roundRect">
-            <a:avLst>
-              <a:gd name="adj" fmla="val 50000"/>
-            </a:avLst>
-          </a:prstGeom>
-          <a:solidFill>
-            <a:srgbClr val="1B2740"/>
-          </a:solidFill>
-          <a:ln>
-            <a:noFill/>
-          </a:ln>
-        </p:spPr>
-        <p:txBody>
-          <a:bodyPr rtlCol="0" anchor="ctr"/>
-          <a:lstStyle/>
-          <a:p>
-            <a:pPr algn="ctr"/>
-          </a:p>
-        </p:txBody>
-      </p:sp>
-      <p:sp>
-        <p:nvSpPr>
-          <p:cNvPr id="112" name="Texto RECUAR"/>
-          <p:cNvSpPr txBox="1"/>
-          <p:nvPr/>
-        </p:nvSpPr>
-        <p:spPr>
-          <a:xfrm>
-            <a:off x="2880360" y="4983480"/>
-            <a:ext cx="1417320" cy="457200"/>
-          </a:xfrm>
-          <a:prstGeom prst="rect">
-            <a:avLst/>
-          </a:prstGeom>
-          <a:noFill/>
-        </p:spPr>
-        <p:txBody>
-          <a:bodyPr vert="horz" wrap="square" lIns="0" tIns="0" rIns="0" bIns="0" anchor="ctr" anchorCtr="0">
-            <a:noAutofit/>
-          </a:bodyPr>
-          <a:lstStyle/>
-          <a:p>
-            <a:pPr marL="0" indent="0" algn="ctr">
-              <a:buNone/>
-            </a:pPr>
-            <a:r>
-              <a:rPr lang="pt-BR" sz="1500" b="1" i="0" u="none" strike="noStrike" kern="1200" cap="none" spc="0" baseline="0">
-                <a:solidFill>
-                  <a:srgbClr val="FFFFFF"/>
-                </a:solidFill>
-                <a:latin typeface="Montserrat Medium"/>
-                <a:ea typeface="Montserrat Medium"/>
-                <a:cs typeface="Montserrat Medium"/>
-                <a:sym typeface="Montserrat Medium"/>
-              </a:rPr>
-              <a:t xml:space="preserve">RECUAR</a:t>
-            </a:r>
-          </a:p>
-        </p:txBody>
-      </p:sp>
-      <p:sp>
-        <p:nvSpPr>
-          <p:cNvPr id="113" name="Intenção DEFENDER"/>
-          <p:cNvSpPr/>
-          <p:nvPr/>
-        </p:nvSpPr>
-        <p:spPr>
-          <a:xfrm>
-            <a:off x="4462272" y="4983480"/>
-            <a:ext cx="1417320" cy="457200"/>
-          </a:xfrm>
-          <a:prstGeom prst="roundRect">
-            <a:avLst>
-              <a:gd name="adj" fmla="val 50000"/>
-            </a:avLst>
-          </a:prstGeom>
-          <a:solidFill>
-            <a:srgbClr val="1B2740"/>
-          </a:solidFill>
-          <a:ln>
-            <a:noFill/>
-          </a:ln>
-        </p:spPr>
-        <p:txBody>
-          <a:bodyPr rtlCol="0" anchor="ctr"/>
-          <a:lstStyle/>
-          <a:p>
-            <a:pPr algn="ctr"/>
-          </a:p>
-        </p:txBody>
-      </p:sp>
-      <p:sp>
-        <p:nvSpPr>
-          <p:cNvPr id="114" name="Texto DEFENDER"/>
-          <p:cNvSpPr txBox="1"/>
-          <p:nvPr/>
-        </p:nvSpPr>
-        <p:spPr>
-          <a:xfrm>
-            <a:off x="4462272" y="4983480"/>
-            <a:ext cx="1417320" cy="457200"/>
-          </a:xfrm>
-          <a:prstGeom prst="rect">
-            <a:avLst/>
-          </a:prstGeom>
-          <a:noFill/>
-        </p:spPr>
-        <p:txBody>
-          <a:bodyPr vert="horz" wrap="square" lIns="0" tIns="0" rIns="0" bIns="0" anchor="ctr" anchorCtr="0">
-            <a:noAutofit/>
-          </a:bodyPr>
-          <a:lstStyle/>
-          <a:p>
-            <a:pPr marL="0" indent="0" algn="ctr">
-              <a:buNone/>
-            </a:pPr>
-            <a:r>
-              <a:rPr lang="pt-BR" sz="1500" b="1" i="0" u="none" strike="noStrike" kern="1200" cap="none" spc="0" baseline="0">
-                <a:solidFill>
-                  <a:srgbClr val="FFFFFF"/>
-                </a:solidFill>
-                <a:latin typeface="Montserrat Medium"/>
-                <a:ea typeface="Montserrat Medium"/>
-                <a:cs typeface="Montserrat Medium"/>
-                <a:sym typeface="Montserrat Medium"/>
-              </a:rPr>
-              <a:t xml:space="preserve">DEFENDER</a:t>
-            </a:r>
-          </a:p>
-        </p:txBody>
-      </p:sp>
-      <p:sp>
-        <p:nvSpPr>
-          <p:cNvPr id="115" name="Genes"/>
-          <p:cNvSpPr txBox="1"/>
-          <p:nvPr/>
-        </p:nvSpPr>
-        <p:spPr>
-          <a:xfrm>
-            <a:off x="1348740" y="5852160"/>
-            <a:ext cx="2011680" cy="640080"/>
-          </a:xfrm>
-          <a:prstGeom prst="rect">
-            <a:avLst/>
-          </a:prstGeom>
-          <a:noFill/>
-        </p:spPr>
-        <p:txBody>
-          <a:bodyPr vert="horz" wrap="square" lIns="0" tIns="0" rIns="0" bIns="0" anchor="t" anchorCtr="0">
-            <a:noAutofit/>
-          </a:bodyPr>
-          <a:lstStyle/>
-          <a:p>
             <a:pPr marL="0" indent="0" algn="l">
               <a:buNone/>
             </a:pPr>
             <a:r>
-              <a:rPr lang="pt-BR" sz="4000" b="1" i="0" u="none" strike="noStrike" kern="1200" cap="none" spc="0" baseline="0">
+              <a:rPr lang="pt-BR" sz="5400" b="1" i="0" u="none" strike="noStrike" kern="1200" cap="none" spc="0" baseline="0">
                 <a:solidFill>
                   <a:srgbClr val="1B2740"/>
                 </a:solidFill>
@@ -19421,14 +19191,14 @@
       </p:sp>
       <p:sp>
         <p:nvSpPr>
-          <p:cNvPr id="116" name="Genes legenda"/>
+          <p:cNvPr id="110" name="Genes legenda"/>
           <p:cNvSpPr txBox="1"/>
           <p:nvPr/>
         </p:nvSpPr>
         <p:spPr>
           <a:xfrm>
-            <a:off x="1348740" y="6492240"/>
-            <a:ext cx="2194560" cy="822960"/>
+            <a:off x="2994660" y="4983480"/>
+            <a:ext cx="2697480" cy="868680"/>
           </a:xfrm>
           <a:prstGeom prst="rect">
             <a:avLst/>
@@ -19436,7 +19206,7 @@
           <a:noFill/>
         </p:spPr>
         <p:txBody>
-          <a:bodyPr vert="horz" wrap="square" lIns="0" tIns="0" rIns="0" bIns="0" anchor="t" anchorCtr="0">
+          <a:bodyPr vert="horz" wrap="square" lIns="0" tIns="0" rIns="0" bIns="0" anchor="ctr" anchorCtr="0">
             <a:noAutofit/>
           </a:bodyPr>
           <a:lstStyle/>
@@ -19445,9 +19215,9 @@
               <a:buNone/>
             </a:pPr>
             <a:r>
-              <a:rPr lang="pt-BR" sz="1800" b="0" i="0" u="none" strike="noStrike" kern="1200" cap="none" spc="0" baseline="0">
-                <a:solidFill>
-                  <a:srgbClr val="5B6178"/>
+              <a:rPr lang="pt-BR" sz="2800" b="0" i="0" u="none" strike="noStrike" kern="1200" cap="none" spc="0" baseline="0">
+                <a:solidFill>
+                  <a:srgbClr val="1B2740"/>
                 </a:solidFill>
                 <a:latin typeface="Montserrat Medium"/>
                 <a:ea typeface="Montserrat Medium"/>
@@ -19462,9 +19232,9 @@
               <a:buNone/>
             </a:pPr>
             <a:r>
-              <a:rPr lang="pt-BR" sz="1800" b="0" i="0" u="none" strike="noStrike" kern="1200" cap="none" spc="0" baseline="0">
-                <a:solidFill>
-                  <a:srgbClr val="5B6178"/>
+              <a:rPr lang="pt-BR" sz="2800" b="0" i="0" u="none" strike="noStrike" kern="1200" cap="none" spc="0" baseline="0">
+                <a:solidFill>
+                  <a:srgbClr val="1B2740"/>
                 </a:solidFill>
                 <a:latin typeface="Montserrat Medium"/>
                 <a:ea typeface="Montserrat Medium"/>
@@ -19478,14 +19248,14 @@
       </p:sp>
       <p:sp>
         <p:nvSpPr>
-          <p:cNvPr id="117" name="Lutas"/>
+          <p:cNvPr id="111" name="Lutas"/>
           <p:cNvSpPr txBox="1"/>
           <p:nvPr/>
         </p:nvSpPr>
         <p:spPr>
           <a:xfrm>
-            <a:off x="3360420" y="5852160"/>
-            <a:ext cx="2651760" cy="640080"/>
+            <a:off x="1348740" y="6263640"/>
+            <a:ext cx="1600200" cy="868680"/>
           </a:xfrm>
           <a:prstGeom prst="rect">
             <a:avLst/>
@@ -19493,7 +19263,7 @@
           <a:noFill/>
         </p:spPr>
         <p:txBody>
-          <a:bodyPr vert="horz" wrap="square" lIns="0" tIns="0" rIns="0" bIns="0" anchor="t" anchorCtr="0">
+          <a:bodyPr vert="horz" wrap="square" lIns="0" tIns="0" rIns="0" bIns="0" anchor="ctr" anchorCtr="0">
             <a:noAutofit/>
           </a:bodyPr>
           <a:lstStyle/>
@@ -19502,7 +19272,7 @@
               <a:buNone/>
             </a:pPr>
             <a:r>
-              <a:rPr lang="pt-BR" sz="4000" b="1" i="0" u="none" strike="noStrike" kern="1200" cap="none" spc="0" baseline="0">
+              <a:rPr lang="pt-BR" sz="5400" b="1" i="0" u="none" strike="noStrike" kern="1200" cap="none" spc="0" baseline="0">
                 <a:solidFill>
                   <a:srgbClr val="1B2740"/>
                 </a:solidFill>
@@ -19511,21 +19281,21 @@
                 <a:cs typeface="Montserrat Medium"/>
                 <a:sym typeface="Montserrat Medium"/>
               </a:rPr>
-              <a:t xml:space="preserve">10 × 150</a:t>
-            </a:r>
-          </a:p>
-        </p:txBody>
-      </p:sp>
-      <p:sp>
-        <p:nvSpPr>
-          <p:cNvPr id="118" name="Lutas legenda"/>
+              <a:t xml:space="preserve">150</a:t>
+            </a:r>
+          </a:p>
+        </p:txBody>
+      </p:sp>
+      <p:sp>
+        <p:nvSpPr>
+          <p:cNvPr id="112" name="Lutas legenda"/>
           <p:cNvSpPr txBox="1"/>
           <p:nvPr/>
         </p:nvSpPr>
         <p:spPr>
           <a:xfrm>
-            <a:off x="3360420" y="6492240"/>
-            <a:ext cx="2377440" cy="822960"/>
+            <a:off x="2994660" y="6263640"/>
+            <a:ext cx="2697480" cy="868680"/>
           </a:xfrm>
           <a:prstGeom prst="rect">
             <a:avLst/>
@@ -19533,7 +19303,7 @@
           <a:noFill/>
         </p:spPr>
         <p:txBody>
-          <a:bodyPr vert="horz" wrap="square" lIns="0" tIns="0" rIns="0" bIns="0" anchor="t" anchorCtr="0">
+          <a:bodyPr vert="horz" wrap="square" lIns="0" tIns="0" rIns="0" bIns="0" anchor="ctr" anchorCtr="0">
             <a:noAutofit/>
           </a:bodyPr>
           <a:lstStyle/>
@@ -19542,16 +19312,16 @@
               <a:buNone/>
             </a:pPr>
             <a:r>
-              <a:rPr lang="pt-BR" sz="1800" b="0" i="0" u="none" strike="noStrike" kern="1200" cap="none" spc="0" baseline="0">
-                <a:solidFill>
-                  <a:srgbClr val="5B6178"/>
+              <a:rPr lang="pt-BR" sz="2800" b="0" i="0" u="none" strike="noStrike" kern="1200" cap="none" spc="0" baseline="0">
+                <a:solidFill>
+                  <a:srgbClr val="1B2740"/>
                 </a:solidFill>
                 <a:latin typeface="Montserrat Medium"/>
                 <a:ea typeface="Montserrat Medium"/>
                 <a:cs typeface="Montserrat Medium"/>
                 <a:sym typeface="Montserrat Medium"/>
               </a:rPr>
-              <a:t xml:space="preserve">confrontos × lutas</a:t>
+              <a:t xml:space="preserve">lutas por</a:t>
             </a:r>
           </a:p>
           <a:p>
@@ -19559,35 +19329,35 @@
               <a:buNone/>
             </a:pPr>
             <a:r>
-              <a:rPr lang="pt-BR" sz="1800" b="0" i="0" u="none" strike="noStrike" kern="1200" cap="none" spc="0" baseline="0">
-                <a:solidFill>
-                  <a:srgbClr val="5B6178"/>
+              <a:rPr lang="pt-BR" sz="2800" b="0" i="0" u="none" strike="noStrike" kern="1200" cap="none" spc="0" baseline="0">
+                <a:solidFill>
+                  <a:srgbClr val="1B2740"/>
                 </a:solidFill>
                 <a:latin typeface="Montserrat Medium"/>
                 <a:ea typeface="Montserrat Medium"/>
                 <a:cs typeface="Montserrat Medium"/>
                 <a:sym typeface="Montserrat Medium"/>
               </a:rPr>
-              <a:t xml:space="preserve">por elenco</a:t>
+              <a:t xml:space="preserve">confronto</a:t>
             </a:r>
           </a:p>
         </p:txBody>
       </p:sp>
       <p:cxnSp>
         <p:nvCxnSpPr>
-          <p:cNvPr id="119" name="Seta 1"/>
+          <p:cNvPr id="113" name="Seta 1"/>
           <p:cNvCxnSpPr/>
           <p:nvPr/>
         </p:nvCxnSpPr>
         <p:spPr>
           <a:xfrm>
-            <a:off x="6327648" y="5554980"/>
+            <a:off x="6080760" y="5600700"/>
             <a:ext cx="457200" cy="0"/>
           </a:xfrm>
           <a:prstGeom prst="line">
             <a:avLst/>
           </a:prstGeom>
-          <a:ln w="47625">
+          <a:ln w="57150">
             <a:solidFill>
               <a:srgbClr val="1B2740"/>
             </a:solidFill>
@@ -19597,14 +19367,14 @@
       </p:cxnSp>
       <p:sp>
         <p:nvSpPr>
-          <p:cNvPr id="120" name="Rótulo busca"/>
+          <p:cNvPr id="114" name="Rótulo busca"/>
           <p:cNvSpPr txBox="1"/>
           <p:nvPr/>
         </p:nvSpPr>
         <p:spPr>
           <a:xfrm>
-            <a:off x="6967728" y="3017520"/>
-            <a:ext cx="5120640" cy="329184"/>
+            <a:off x="6720840" y="2926080"/>
+            <a:ext cx="5394960" cy="411480"/>
           </a:xfrm>
           <a:prstGeom prst="rect">
             <a:avLst/>
@@ -19621,7 +19391,7 @@
               <a:buNone/>
             </a:pPr>
             <a:r>
-              <a:rPr lang="pt-BR" sz="2000" b="1" i="0" u="none" strike="noStrike" kern="1200" cap="none" spc="0" baseline="0">
+              <a:rPr lang="pt-BR" sz="2800" b="1" i="0" u="none" strike="noStrike" kern="1200" cap="none" spc="0" baseline="0">
                 <a:solidFill>
                   <a:srgbClr val="685BC7"/>
                 </a:solidFill>
@@ -19637,14 +19407,14 @@
       </p:sp>
       <p:sp>
         <p:nvSpPr>
-          <p:cNvPr id="121" name="Busca"/>
+          <p:cNvPr id="115" name="Busca"/>
           <p:cNvSpPr/>
           <p:nvPr/>
         </p:nvSpPr>
         <p:spPr>
           <a:xfrm>
-            <a:off x="6967728" y="3474720"/>
-            <a:ext cx="5120640" cy="4160520"/>
+            <a:off x="6720840" y="3474720"/>
+            <a:ext cx="5394960" cy="4251960"/>
           </a:xfrm>
           <a:prstGeom prst="roundRect">
             <a:avLst>
@@ -19668,18 +19438,18 @@
       </p:sp>
       <p:sp>
         <p:nvSpPr>
-          <p:cNvPr id="122" name="Objetivo equilíbrio"/>
+          <p:cNvPr id="116" name="Objetivo equilíbrio"/>
           <p:cNvSpPr/>
           <p:nvPr/>
         </p:nvSpPr>
         <p:spPr>
           <a:xfrm>
-            <a:off x="7242048" y="3749040"/>
-            <a:ext cx="4572000" cy="1325880"/>
+            <a:off x="6995160" y="3749040"/>
+            <a:ext cx="4846320" cy="1691640"/>
           </a:xfrm>
           <a:prstGeom prst="roundRect">
             <a:avLst>
-              <a:gd name="adj" fmla="val 10000"/>
+              <a:gd name="adj" fmla="val 9000"/>
             </a:avLst>
           </a:prstGeom>
           <a:solidFill>
@@ -19699,14 +19469,14 @@
       </p:sp>
       <p:sp>
         <p:nvSpPr>
-          <p:cNvPr id="123" name="Equilíbrio título"/>
+          <p:cNvPr id="117" name="Equilíbrio título"/>
           <p:cNvSpPr txBox="1"/>
           <p:nvPr/>
         </p:nvSpPr>
         <p:spPr>
           <a:xfrm>
-            <a:off x="7516368" y="3931920"/>
-            <a:ext cx="4023360" cy="457200"/>
+            <a:off x="7269480" y="3977640"/>
+            <a:ext cx="4297680" cy="594360"/>
           </a:xfrm>
           <a:prstGeom prst="rect">
             <a:avLst/>
@@ -19723,7 +19493,7 @@
               <a:buNone/>
             </a:pPr>
             <a:r>
-              <a:rPr lang="pt-BR" sz="2600" b="1" i="0" u="none" strike="noStrike" kern="1200" cap="none" spc="0" baseline="0">
+              <a:rPr lang="pt-BR" sz="3200" b="1" i="0" u="none" strike="noStrike" kern="1200" cap="none" spc="0" baseline="0">
                 <a:solidFill>
                   <a:srgbClr val="C8540F"/>
                 </a:solidFill>
@@ -19732,21 +19502,21 @@
                 <a:cs typeface="Montserrat Medium"/>
                 <a:sym typeface="Montserrat Medium"/>
               </a:rPr>
-              <a:t xml:space="preserve">ficar equilibrado</a:t>
-            </a:r>
-          </a:p>
-        </p:txBody>
-      </p:sp>
-      <p:sp>
-        <p:nvSpPr>
-          <p:cNvPr id="124" name="Equilíbrio legenda"/>
+              <a:t xml:space="preserve">equilibrado</a:t>
+            </a:r>
+          </a:p>
+        </p:txBody>
+      </p:sp>
+      <p:sp>
+        <p:nvSpPr>
+          <p:cNvPr id="118" name="Equilíbrio legenda"/>
           <p:cNvSpPr txBox="1"/>
           <p:nvPr/>
         </p:nvSpPr>
         <p:spPr>
           <a:xfrm>
-            <a:off x="7516368" y="4480560"/>
-            <a:ext cx="4023360" cy="365760"/>
+            <a:off x="7269480" y="4617720"/>
+            <a:ext cx="4297680" cy="457200"/>
           </a:xfrm>
           <a:prstGeom prst="rect">
             <a:avLst/>
@@ -19763,7 +19533,7 @@
               <a:buNone/>
             </a:pPr>
             <a:r>
-              <a:rPr lang="pt-BR" sz="1800" b="0" i="0" u="none" strike="noStrike" kern="1200" cap="none" spc="0" baseline="0">
+              <a:rPr lang="pt-BR" sz="2800" b="0" i="0" u="none" strike="noStrike" kern="1200" cap="none" spc="0" baseline="0">
                 <a:solidFill>
                   <a:srgbClr val="1B2740"/>
                 </a:solidFill>
@@ -19772,25 +19542,25 @@
                 <a:cs typeface="Montserrat Medium"/>
                 <a:sym typeface="Montserrat Medium"/>
               </a:rPr>
-              <a:t xml:space="preserve">desbalanço baixo</a:t>
-            </a:r>
-          </a:p>
-        </p:txBody>
-      </p:sp>
-      <p:sp>
-        <p:nvSpPr>
-          <p:cNvPr id="125" name="Objetivo identidade"/>
+              <a:t xml:space="preserve">ninguém domina</a:t>
+            </a:r>
+          </a:p>
+        </p:txBody>
+      </p:sp>
+      <p:sp>
+        <p:nvSpPr>
+          <p:cNvPr id="119" name="Objetivo identidade"/>
           <p:cNvSpPr/>
           <p:nvPr/>
         </p:nvSpPr>
         <p:spPr>
           <a:xfrm>
-            <a:off x="7242048" y="5257800"/>
-            <a:ext cx="4572000" cy="1325880"/>
+            <a:off x="6995160" y="5760720"/>
+            <a:ext cx="4846320" cy="1691640"/>
           </a:xfrm>
           <a:prstGeom prst="roundRect">
             <a:avLst>
-              <a:gd name="adj" fmla="val 10000"/>
+              <a:gd name="adj" fmla="val 9000"/>
             </a:avLst>
           </a:prstGeom>
           <a:solidFill>
@@ -19810,14 +19580,14 @@
       </p:sp>
       <p:sp>
         <p:nvSpPr>
-          <p:cNvPr id="126" name="Identidade título"/>
+          <p:cNvPr id="120" name="Identidade título"/>
           <p:cNvSpPr txBox="1"/>
           <p:nvPr/>
         </p:nvSpPr>
         <p:spPr>
           <a:xfrm>
-            <a:off x="7516368" y="5440680"/>
-            <a:ext cx="4023360" cy="457200"/>
+            <a:off x="7269480" y="5989320"/>
+            <a:ext cx="4297680" cy="594360"/>
           </a:xfrm>
           <a:prstGeom prst="rect">
             <a:avLst/>
@@ -19834,7 +19604,7 @@
               <a:buNone/>
             </a:pPr>
             <a:r>
-              <a:rPr lang="pt-BR" sz="2600" b="1" i="0" u="none" strike="noStrike" kern="1200" cap="none" spc="0" baseline="0">
+              <a:rPr lang="pt-BR" sz="3200" b="1" i="0" u="none" strike="noStrike" kern="1200" cap="none" spc="0" baseline="0">
                 <a:solidFill>
                   <a:srgbClr val="685BC7"/>
                 </a:solidFill>
@@ -19843,21 +19613,21 @@
                 <a:cs typeface="Montserrat Medium"/>
                 <a:sym typeface="Montserrat Medium"/>
               </a:rPr>
-              <a:t xml:space="preserve">ficar perto do original</a:t>
-            </a:r>
-          </a:p>
-        </p:txBody>
-      </p:sp>
-      <p:sp>
-        <p:nvSpPr>
-          <p:cNvPr id="127" name="Identidade legenda"/>
+              <a:t xml:space="preserve">perto do original</a:t>
+            </a:r>
+          </a:p>
+        </p:txBody>
+      </p:sp>
+      <p:sp>
+        <p:nvSpPr>
+          <p:cNvPr id="121" name="Identidade legenda"/>
           <p:cNvSpPr txBox="1"/>
           <p:nvPr/>
         </p:nvSpPr>
         <p:spPr>
           <a:xfrm>
-            <a:off x="7516368" y="5989320"/>
-            <a:ext cx="4023360" cy="365760"/>
+            <a:off x="7269480" y="6629400"/>
+            <a:ext cx="4297680" cy="457200"/>
           </a:xfrm>
           <a:prstGeom prst="rect">
             <a:avLst/>
@@ -19874,7 +19644,7 @@
               <a:buNone/>
             </a:pPr>
             <a:r>
-              <a:rPr lang="pt-BR" sz="1800" b="0" i="0" u="none" strike="noStrike" kern="1200" cap="none" spc="0" baseline="0">
+              <a:rPr lang="pt-BR" sz="2800" b="0" i="0" u="none" strike="noStrike" kern="1200" cap="none" spc="0" baseline="0">
                 <a:solidFill>
                   <a:srgbClr val="1B2740"/>
                 </a:solidFill>
@@ -19883,66 +19653,26 @@
                 <a:cs typeface="Montserrat Medium"/>
                 <a:sym typeface="Montserrat Medium"/>
               </a:rPr>
-              <a:t xml:space="preserve">afastar-se custa, mas pode</a:t>
-            </a:r>
-          </a:p>
-        </p:txBody>
-      </p:sp>
-      <p:sp>
-        <p:nvSpPr>
-          <p:cNvPr id="128" name="Ciclo"/>
-          <p:cNvSpPr txBox="1"/>
-          <p:nvPr/>
-        </p:nvSpPr>
-        <p:spPr>
-          <a:xfrm>
-            <a:off x="7242048" y="6858000"/>
-            <a:ext cx="4572000" cy="365760"/>
-          </a:xfrm>
-          <a:prstGeom prst="rect">
-            <a:avLst/>
-          </a:prstGeom>
-          <a:noFill/>
-        </p:spPr>
-        <p:txBody>
-          <a:bodyPr vert="horz" wrap="square" lIns="0" tIns="0" rIns="0" bIns="0" anchor="t" anchorCtr="0">
-            <a:noAutofit/>
-          </a:bodyPr>
-          <a:lstStyle/>
-          <a:p>
-            <a:pPr marL="0" indent="0" algn="ctr">
-              <a:buNone/>
-            </a:pPr>
-            <a:r>
-              <a:rPr lang="pt-BR" sz="1800" b="0" i="0" u="none" strike="noStrike" kern="1200" cap="none" spc="0" baseline="0">
-                <a:solidFill>
-                  <a:srgbClr val="5B6178"/>
-                </a:solidFill>
-                <a:latin typeface="Montserrat Medium"/>
-                <a:ea typeface="Montserrat Medium"/>
-                <a:cs typeface="Montserrat Medium"/>
-                <a:sym typeface="Montserrat Medium"/>
-              </a:rPr>
-              <a:t xml:space="preserve">gera · cruza · muta · repete</a:t>
+              <a:t xml:space="preserve">afastar-se custa</a:t>
             </a:r>
           </a:p>
         </p:txBody>
       </p:sp>
       <p:cxnSp>
         <p:nvCxnSpPr>
-          <p:cNvPr id="129" name="Seta 2"/>
+          <p:cNvPr id="122" name="Seta 2"/>
           <p:cNvCxnSpPr/>
           <p:nvPr/>
         </p:nvCxnSpPr>
         <p:spPr>
           <a:xfrm>
-            <a:off x="12271248" y="5554980"/>
+            <a:off x="12298680" y="5600700"/>
             <a:ext cx="457200" cy="0"/>
           </a:xfrm>
           <a:prstGeom prst="line">
             <a:avLst/>
           </a:prstGeom>
-          <a:ln w="47625">
+          <a:ln w="57150">
             <a:solidFill>
               <a:srgbClr val="1B2740"/>
             </a:solidFill>
@@ -19953,14 +19683,14 @@
       </p:cxnSp>
       <p:sp>
         <p:nvSpPr>
-          <p:cNvPr id="130" name="Rótulo depois"/>
+          <p:cNvPr id="123" name="Rótulo depois"/>
           <p:cNvSpPr txBox="1"/>
           <p:nvPr/>
         </p:nvSpPr>
         <p:spPr>
           <a:xfrm>
-            <a:off x="12911328" y="3017520"/>
-            <a:ext cx="4347972" cy="329184"/>
+            <a:off x="12938760" y="2926080"/>
+            <a:ext cx="4320540" cy="411480"/>
           </a:xfrm>
           <a:prstGeom prst="rect">
             <a:avLst/>
@@ -19977,7 +19707,7 @@
               <a:buNone/>
             </a:pPr>
             <a:r>
-              <a:rPr lang="pt-BR" sz="2000" b="1" i="0" u="none" strike="noStrike" kern="1200" cap="none" spc="0" baseline="0">
+              <a:rPr lang="pt-BR" sz="2800" b="1" i="0" u="none" strike="noStrike" kern="1200" cap="none" spc="0" baseline="0">
                 <a:solidFill>
                   <a:srgbClr val="685BC7"/>
                 </a:solidFill>
@@ -19993,14 +19723,14 @@
       </p:sp>
       <p:sp>
         <p:nvSpPr>
-          <p:cNvPr id="131" name="Fora da busca"/>
+          <p:cNvPr id="124" name="Fora da busca"/>
           <p:cNvSpPr/>
           <p:nvPr/>
         </p:nvSpPr>
         <p:spPr>
           <a:xfrm>
-            <a:off x="12911328" y="3474720"/>
-            <a:ext cx="4347972" cy="4160520"/>
+            <a:off x="12938760" y="3474720"/>
+            <a:ext cx="4320540" cy="4251960"/>
           </a:xfrm>
           <a:prstGeom prst="roundRect">
             <a:avLst>
@@ -20010,7 +19740,7 @@
           <a:solidFill>
             <a:srgbClr val="FFFFFF"/>
           </a:solidFill>
-          <a:ln w="33020">
+          <a:ln w="38100">
             <a:solidFill>
               <a:srgbClr val="685BC7"/>
             </a:solidFill>
@@ -20027,14 +19757,14 @@
       </p:sp>
       <p:sp>
         <p:nvSpPr>
-          <p:cNvPr id="132" name="Nunca vê"/>
+          <p:cNvPr id="125" name="Fora"/>
           <p:cNvSpPr txBox="1"/>
           <p:nvPr/>
         </p:nvSpPr>
         <p:spPr>
           <a:xfrm>
-            <a:off x="13231368" y="4160520"/>
-            <a:ext cx="3707892" cy="365760"/>
+            <a:off x="13258800" y="3794760"/>
+            <a:ext cx="3680460" cy="457200"/>
           </a:xfrm>
           <a:prstGeom prst="rect">
             <a:avLst/>
@@ -20051,7 +19781,7 @@
               <a:buNone/>
             </a:pPr>
             <a:r>
-              <a:rPr lang="pt-BR" sz="1800" b="0" i="0" u="none" strike="noStrike" kern="1200" cap="none" spc="0" baseline="0">
+              <a:rPr lang="pt-BR" sz="2800" b="0" i="0" u="none" strike="noStrike" kern="1200" cap="none" spc="0" baseline="0">
                 <a:solidFill>
                   <a:srgbClr val="5B6178"/>
                 </a:solidFill>
@@ -20060,21 +19790,21 @@
                 <a:cs typeface="Montserrat Medium"/>
                 <a:sym typeface="Montserrat Medium"/>
               </a:rPr>
-              <a:t xml:space="preserve">o algoritmo nunca vê:</a:t>
-            </a:r>
-          </a:p>
-        </p:txBody>
-      </p:sp>
-      <p:sp>
-        <p:nvSpPr>
-          <p:cNvPr id="133" name="Quem vence"/>
+              <a:t xml:space="preserve">fora da busca:</a:t>
+            </a:r>
+          </a:p>
+        </p:txBody>
+      </p:sp>
+      <p:sp>
+        <p:nvSpPr>
+          <p:cNvPr id="126" name="Quem vence"/>
           <p:cNvSpPr txBox="1"/>
           <p:nvPr/>
         </p:nvSpPr>
         <p:spPr>
           <a:xfrm>
-            <a:off x="13231368" y="4754880"/>
-            <a:ext cx="3707892" cy="914400"/>
+            <a:off x="13258800" y="4434840"/>
+            <a:ext cx="3680460" cy="1051560"/>
           </a:xfrm>
           <a:prstGeom prst="rect">
             <a:avLst/>
@@ -20094,7 +19824,7 @@
               <a:buNone/>
             </a:pPr>
             <a:r>
-              <a:rPr lang="pt-BR" sz="2600" b="1" i="0" u="none" strike="noStrike" kern="1200" cap="none" spc="0" baseline="0">
+              <a:rPr lang="pt-BR" sz="3200" b="1" i="0" u="none" strike="noStrike" kern="1200" cap="none" spc="0" baseline="0">
                 <a:solidFill>
                   <a:srgbClr val="1B2740"/>
                 </a:solidFill>
@@ -20114,7 +19844,7 @@
               <a:buNone/>
             </a:pPr>
             <a:r>
-              <a:rPr lang="pt-BR" sz="2600" b="1" i="0" u="none" strike="noStrike" kern="1200" cap="none" spc="0" baseline="0">
+              <a:rPr lang="pt-BR" sz="3200" b="1" i="0" u="none" strike="noStrike" kern="1200" cap="none" spc="0" baseline="0">
                 <a:solidFill>
                   <a:srgbClr val="1B2740"/>
                 </a:solidFill>
@@ -20130,14 +19860,14 @@
       </p:sp>
       <p:sp>
         <p:nvSpPr>
-          <p:cNvPr id="134" name="Testes"/>
+          <p:cNvPr id="127" name="Testes"/>
           <p:cNvSpPr txBox="1"/>
           <p:nvPr/>
         </p:nvSpPr>
         <p:spPr>
           <a:xfrm>
-            <a:off x="13231368" y="5989320"/>
-            <a:ext cx="3707892" cy="914400"/>
+            <a:off x="13258800" y="5806440"/>
+            <a:ext cx="3680460" cy="1051560"/>
           </a:xfrm>
           <a:prstGeom prst="rect">
             <a:avLst/>
@@ -20157,7 +19887,7 @@
               <a:buNone/>
             </a:pPr>
             <a:r>
-              <a:rPr lang="pt-BR" sz="2600" b="1" i="0" u="none" strike="noStrike" kern="1200" cap="none" spc="0" baseline="0">
+              <a:rPr lang="pt-BR" sz="3200" b="1" i="0" u="none" strike="noStrike" kern="1200" cap="none" spc="0" baseline="0">
                 <a:solidFill>
                   <a:srgbClr val="1B2740"/>
                 </a:solidFill>
@@ -20177,7 +19907,7 @@
               <a:buNone/>
             </a:pPr>
             <a:r>
-              <a:rPr lang="pt-BR" sz="2600" b="1" i="0" u="none" strike="noStrike" kern="1200" cap="none" spc="0" baseline="0">
+              <a:rPr lang="pt-BR" sz="3200" b="1" i="0" u="none" strike="noStrike" kern="1200" cap="none" spc="0" baseline="0">
                 <a:solidFill>
                   <a:srgbClr val="1B2740"/>
                 </a:solidFill>
@@ -20193,14 +19923,14 @@
       </p:sp>
       <p:sp>
         <p:nvSpPr>
-          <p:cNvPr id="135" name="Fecho"/>
+          <p:cNvPr id="128" name="Fecho"/>
           <p:cNvSpPr txBox="1"/>
           <p:nvPr/>
         </p:nvSpPr>
         <p:spPr>
           <a:xfrm>
-            <a:off x="1028700" y="8046720"/>
-            <a:ext cx="16230600" cy="822960"/>
+            <a:off x="1028700" y="8001000"/>
+            <a:ext cx="16230600" cy="1188720"/>
           </a:xfrm>
           <a:prstGeom prst="rect">
             <a:avLst/>
@@ -20217,7 +19947,7 @@
               <a:buNone/>
             </a:pPr>
             <a:r>
-              <a:rPr lang="pt-BR" sz="2600" b="0" i="0" u="none" strike="noStrike" kern="1200" cap="none" spc="0" baseline="0">
+              <a:rPr lang="pt-BR" sz="3000" b="0" i="0" u="none" strike="noStrike" kern="1200" cap="none" spc="0" baseline="0">
                 <a:solidFill>
                   <a:srgbClr val="1B2740"/>
                 </a:solidFill>
@@ -20229,7 +19959,7 @@
               <a:t xml:space="preserve">Se a identidade fosse regra, sobreviveria por obrigação. </a:t>
             </a:r>
             <a:r>
-              <a:rPr lang="pt-BR" sz="2600" b="1" i="0" u="none" strike="noStrike" kern="1200" cap="none" spc="0" baseline="0">
+              <a:rPr lang="pt-BR" sz="3000" b="1" i="0" u="none" strike="noStrike" kern="1200" cap="none" spc="0" baseline="0">
                 <a:solidFill>
                   <a:srgbClr val="685BC7"/>
                 </a:solidFill>
@@ -23440,14 +23170,14 @@
       </p:sp>
       <p:sp>
         <p:nvSpPr>
-          <p:cNvPr id="10" name="Afirmação"/>
+          <p:cNvPr id="101" name="Afirmação"/>
           <p:cNvSpPr txBox="1"/>
           <p:nvPr/>
         </p:nvSpPr>
         <p:spPr>
           <a:xfrm>
-            <a:off x="1028700" y="1581150"/>
-            <a:ext cx="16230600" cy="1219200"/>
+            <a:off x="1028700" y="1580998"/>
+            <a:ext cx="16230600" cy="1218895"/>
           </a:xfrm>
           <a:prstGeom prst="rect">
             <a:avLst/>
@@ -23473,25 +23203,25 @@
                 <a:cs typeface="Montserrat Medium"/>
                 <a:sym typeface="Montserrat Medium"/>
               </a:rPr>
-              <a:t>Equilibrar por completo apaga boa parte da identidade</a:t>
-            </a:r>
-          </a:p>
-        </p:txBody>
-      </p:sp>
-      <p:sp>
-        <p:nvSpPr>
-          <p:cNvPr id="11" name="Elenco canônico"/>
+              <a:t xml:space="preserve">Equilibrar por completo apaga boa parte da identidade</a:t>
+            </a:r>
+          </a:p>
+        </p:txBody>
+      </p:sp>
+      <p:sp>
+        <p:nvSpPr>
+          <p:cNvPr id="102" name="Cartão canônico"/>
           <p:cNvSpPr/>
           <p:nvPr/>
         </p:nvSpPr>
         <p:spPr>
           <a:xfrm>
-            <a:off x="1028700" y="3352800"/>
-            <a:ext cx="6953250" cy="4457700"/>
+            <a:off x="1028700" y="3017520"/>
+            <a:ext cx="6949440" cy="4846320"/>
           </a:xfrm>
           <a:prstGeom prst="roundRect">
             <a:avLst>
-              <a:gd name="adj" fmla="val 5128"/>
+              <a:gd name="adj" fmla="val 6000"/>
             </a:avLst>
           </a:prstGeom>
           <a:solidFill>
@@ -23511,14 +23241,14 @@
       </p:sp>
       <p:sp>
         <p:nvSpPr>
-          <p:cNvPr id="12" name="TextBox 11"/>
+          <p:cNvPr id="103" name="Título canônico"/>
           <p:cNvSpPr txBox="1"/>
           <p:nvPr/>
         </p:nvSpPr>
         <p:spPr>
           <a:xfrm>
-            <a:off x="1447800" y="3638550"/>
-            <a:ext cx="6115050" cy="476250"/>
+            <a:off x="1440180" y="3291840"/>
+            <a:ext cx="6126480" cy="548640"/>
           </a:xfrm>
           <a:prstGeom prst="rect">
             <a:avLst/>
@@ -23535,7 +23265,7 @@
               <a:buNone/>
             </a:pPr>
             <a:r>
-              <a:rPr lang="pt-BR" sz="3000" b="1" i="0" u="none" strike="noStrike" kern="1200" cap="none" spc="0" baseline="0">
+              <a:rPr lang="pt-BR" sz="3200" b="1" i="0" u="none" strike="noStrike" kern="1200" cap="none" spc="0" baseline="0">
                 <a:solidFill>
                   <a:srgbClr val="1B2740"/>
                 </a:solidFill>
@@ -23544,21 +23274,21 @@
                 <a:cs typeface="Montserrat Medium"/>
                 <a:sym typeface="Montserrat Medium"/>
               </a:rPr>
-              <a:t>Elenco canônico</a:t>
-            </a:r>
-          </a:p>
-        </p:txBody>
-      </p:sp>
-      <p:sp>
-        <p:nvSpPr>
-          <p:cNvPr id="13" name="TextBox 12"/>
+              <a:t xml:space="preserve">Elenco canônico</a:t>
+            </a:r>
+          </a:p>
+        </p:txBody>
+      </p:sp>
+      <p:sp>
+        <p:nvSpPr>
+          <p:cNvPr id="104" name="Sub canônico"/>
           <p:cNvSpPr txBox="1"/>
           <p:nvPr/>
         </p:nvSpPr>
         <p:spPr>
           <a:xfrm>
-            <a:off x="1447800" y="4133850"/>
-            <a:ext cx="6115050" cy="361950"/>
+            <a:off x="1440180" y="3840480"/>
+            <a:ext cx="6126480" cy="457200"/>
           </a:xfrm>
           <a:prstGeom prst="rect">
             <a:avLst/>
@@ -23575,7 +23305,7 @@
               <a:buNone/>
             </a:pPr>
             <a:r>
-              <a:rPr lang="pt-BR" sz="2200" b="0" i="0" u="none" strike="noStrike" kern="1200" cap="none" spc="0" baseline="0">
+              <a:rPr lang="pt-BR" sz="2800" b="0" i="0" u="none" strike="noStrike" kern="1200" cap="none" spc="0" baseline="0">
                 <a:solidFill>
                   <a:srgbClr val="5B6178"/>
                 </a:solidFill>
@@ -23584,21 +23314,21 @@
                 <a:cs typeface="Montserrat Medium"/>
                 <a:sym typeface="Montserrat Medium"/>
               </a:rPr>
-              <a:t>o original, antes da evolução</a:t>
-            </a:r>
-          </a:p>
-        </p:txBody>
-      </p:sp>
-      <p:sp>
-        <p:nvSpPr>
-          <p:cNvPr id="14" name="TextBox 13"/>
+              <a:t xml:space="preserve">o original, antes da evolução</a:t>
+            </a:r>
+          </a:p>
+        </p:txBody>
+      </p:sp>
+      <p:sp>
+        <p:nvSpPr>
+          <p:cNvPr id="105" name="Número canônico de 10 confrontos"/>
           <p:cNvSpPr txBox="1"/>
           <p:nvPr/>
         </p:nvSpPr>
         <p:spPr>
           <a:xfrm>
-            <a:off x="1447800" y="4610100"/>
-            <a:ext cx="2905125" cy="1943100"/>
+            <a:off x="1440180" y="4434840"/>
+            <a:ext cx="2103120" cy="1417320"/>
           </a:xfrm>
           <a:prstGeom prst="rect">
             <a:avLst/>
@@ -23606,7 +23336,7 @@
           <a:noFill/>
         </p:spPr>
         <p:txBody>
-          <a:bodyPr vert="horz" wrap="square" lIns="0" tIns="0" rIns="0" bIns="0" anchor="t" anchorCtr="0">
+          <a:bodyPr vert="horz" wrap="square" lIns="0" tIns="0" rIns="0" bIns="0" anchor="ctr" anchorCtr="0">
             <a:noAutofit/>
           </a:bodyPr>
           <a:lstStyle/>
@@ -23615,7 +23345,7 @@
               <a:buNone/>
             </a:pPr>
             <a:r>
-              <a:rPr lang="pt-BR" sz="12400" b="1" i="0" u="none" strike="noStrike" kern="1200" cap="none" spc="0" baseline="0">
+              <a:rPr lang="pt-BR" sz="10000" b="1" i="0" u="none" strike="noStrike" kern="1200" cap="none" spc="0" baseline="0">
                 <a:solidFill>
                   <a:srgbClr val="C8540F"/>
                 </a:solidFill>
@@ -23624,21 +23354,21 @@
                 <a:cs typeface="Montserrat Medium"/>
                 <a:sym typeface="Montserrat Medium"/>
               </a:rPr>
-              <a:t>0</a:t>
-            </a:r>
-          </a:p>
-        </p:txBody>
-      </p:sp>
-      <p:sp>
-        <p:nvSpPr>
-          <p:cNvPr id="15" name="TextBox 14"/>
+              <a:t xml:space="preserve">0</a:t>
+            </a:r>
+          </a:p>
+        </p:txBody>
+      </p:sp>
+      <p:sp>
+        <p:nvSpPr>
+          <p:cNvPr id="106" name="Legenda canônico de 10 confrontos"/>
           <p:cNvSpPr txBox="1"/>
           <p:nvPr/>
         </p:nvSpPr>
         <p:spPr>
           <a:xfrm>
-            <a:off x="1447800" y="6515100"/>
-            <a:ext cx="2905125" cy="800100"/>
+            <a:off x="3634740" y="4709160"/>
+            <a:ext cx="4023360" cy="914400"/>
           </a:xfrm>
           <a:prstGeom prst="rect">
             <a:avLst/>
@@ -23646,7 +23376,7 @@
           <a:noFill/>
         </p:spPr>
         <p:txBody>
-          <a:bodyPr vert="horz" wrap="square" lIns="0" tIns="0" rIns="0" bIns="0" anchor="t" anchorCtr="0">
+          <a:bodyPr vert="horz" wrap="square" lIns="0" tIns="0" rIns="0" bIns="0" anchor="ctr" anchorCtr="0">
             <a:noAutofit/>
           </a:bodyPr>
           <a:lstStyle/>
@@ -23655,7 +23385,7 @@
               <a:buNone/>
             </a:pPr>
             <a:r>
-              <a:rPr lang="pt-BR" sz="2400" b="0" i="0" u="none" strike="noStrike" kern="1200" cap="none" spc="0" baseline="0">
+              <a:rPr lang="pt-BR" sz="2800" b="0" i="0" u="none" strike="noStrike" kern="1200" cap="none" spc="0" baseline="0">
                 <a:solidFill>
                   <a:srgbClr val="1B2740"/>
                 </a:solidFill>
@@ -23664,7 +23394,7 @@
                 <a:cs typeface="Montserrat Medium"/>
                 <a:sym typeface="Montserrat Medium"/>
               </a:rPr>
-              <a:t>de 10 confrontos</a:t>
+              <a:t xml:space="preserve">de 10 confrontos</a:t>
             </a:r>
           </a:p>
           <a:p>
@@ -23672,7 +23402,7 @@
               <a:buNone/>
             </a:pPr>
             <a:r>
-              <a:rPr lang="pt-BR" sz="2400" b="0" i="0" u="none" strike="noStrike" kern="1200" cap="none" spc="0" baseline="0">
+              <a:rPr lang="pt-BR" sz="2800" b="0" i="0" u="none" strike="noStrike" kern="1200" cap="none" spc="0" baseline="0">
                 <a:solidFill>
                   <a:srgbClr val="1B2740"/>
                 </a:solidFill>
@@ -23681,21 +23411,21 @@
                 <a:cs typeface="Montserrat Medium"/>
                 <a:sym typeface="Montserrat Medium"/>
               </a:rPr>
-              <a:t>equilibrados</a:t>
-            </a:r>
-          </a:p>
-        </p:txBody>
-      </p:sp>
-      <p:sp>
-        <p:nvSpPr>
-          <p:cNvPr id="16" name="TextBox 15"/>
+              <a:t xml:space="preserve">equilibrados</a:t>
+            </a:r>
+          </a:p>
+        </p:txBody>
+      </p:sp>
+      <p:sp>
+        <p:nvSpPr>
+          <p:cNvPr id="107" name="Número canônico de 21 testes"/>
           <p:cNvSpPr txBox="1"/>
           <p:nvPr/>
         </p:nvSpPr>
         <p:spPr>
           <a:xfrm>
-            <a:off x="4657725" y="4610100"/>
-            <a:ext cx="2905125" cy="1943100"/>
+            <a:off x="1440180" y="6035040"/>
+            <a:ext cx="2103120" cy="1417320"/>
           </a:xfrm>
           <a:prstGeom prst="rect">
             <a:avLst/>
@@ -23703,7 +23433,7 @@
           <a:noFill/>
         </p:spPr>
         <p:txBody>
-          <a:bodyPr vert="horz" wrap="square" lIns="0" tIns="0" rIns="0" bIns="0" anchor="t" anchorCtr="0">
+          <a:bodyPr vert="horz" wrap="square" lIns="0" tIns="0" rIns="0" bIns="0" anchor="ctr" anchorCtr="0">
             <a:noAutofit/>
           </a:bodyPr>
           <a:lstStyle/>
@@ -23712,7 +23442,7 @@
               <a:buNone/>
             </a:pPr>
             <a:r>
-              <a:rPr lang="pt-BR" sz="12400" b="1" i="0" u="none" strike="noStrike" kern="1200" cap="none" spc="0" baseline="0">
+              <a:rPr lang="pt-BR" sz="10000" b="1" i="0" u="none" strike="noStrike" kern="1200" cap="none" spc="0" baseline="0">
                 <a:solidFill>
                   <a:srgbClr val="685BC7"/>
                 </a:solidFill>
@@ -23721,21 +23451,21 @@
                 <a:cs typeface="Montserrat Medium"/>
                 <a:sym typeface="Montserrat Medium"/>
               </a:rPr>
-              <a:t>21</a:t>
-            </a:r>
-          </a:p>
-        </p:txBody>
-      </p:sp>
-      <p:sp>
-        <p:nvSpPr>
-          <p:cNvPr id="17" name="TextBox 16"/>
+              <a:t xml:space="preserve">21</a:t>
+            </a:r>
+          </a:p>
+        </p:txBody>
+      </p:sp>
+      <p:sp>
+        <p:nvSpPr>
+          <p:cNvPr id="108" name="Legenda canônico de 21 testes"/>
           <p:cNvSpPr txBox="1"/>
           <p:nvPr/>
         </p:nvSpPr>
         <p:spPr>
           <a:xfrm>
-            <a:off x="4657725" y="6515100"/>
-            <a:ext cx="2905125" cy="800100"/>
+            <a:off x="3634740" y="6309360"/>
+            <a:ext cx="4023360" cy="914400"/>
           </a:xfrm>
           <a:prstGeom prst="rect">
             <a:avLst/>
@@ -23743,7 +23473,7 @@
           <a:noFill/>
         </p:spPr>
         <p:txBody>
-          <a:bodyPr vert="horz" wrap="square" lIns="0" tIns="0" rIns="0" bIns="0" anchor="t" anchorCtr="0">
+          <a:bodyPr vert="horz" wrap="square" lIns="0" tIns="0" rIns="0" bIns="0" anchor="ctr" anchorCtr="0">
             <a:noAutofit/>
           </a:bodyPr>
           <a:lstStyle/>
@@ -23752,7 +23482,7 @@
               <a:buNone/>
             </a:pPr>
             <a:r>
-              <a:rPr lang="pt-BR" sz="2400" b="0" i="0" u="none" strike="noStrike" kern="1200" cap="none" spc="0" baseline="0">
+              <a:rPr lang="pt-BR" sz="2800" b="0" i="0" u="none" strike="noStrike" kern="1200" cap="none" spc="0" baseline="0">
                 <a:solidFill>
                   <a:srgbClr val="1B2740"/>
                 </a:solidFill>
@@ -23761,7 +23491,7 @@
                 <a:cs typeface="Montserrat Medium"/>
                 <a:sym typeface="Montserrat Medium"/>
               </a:rPr>
-              <a:t>de 21 testes</a:t>
+              <a:t xml:space="preserve">de 21 testes</a:t>
             </a:r>
           </a:p>
           <a:p>
@@ -23769,7 +23499,7 @@
               <a:buNone/>
             </a:pPr>
             <a:r>
-              <a:rPr lang="pt-BR" sz="2400" b="0" i="0" u="none" strike="noStrike" kern="1200" cap="none" spc="0" baseline="0">
+              <a:rPr lang="pt-BR" sz="2800" b="0" i="0" u="none" strike="noStrike" kern="1200" cap="none" spc="0" baseline="0">
                 <a:solidFill>
                   <a:srgbClr val="1B2740"/>
                 </a:solidFill>
@@ -23778,25 +23508,25 @@
                 <a:cs typeface="Montserrat Medium"/>
                 <a:sym typeface="Montserrat Medium"/>
               </a:rPr>
-              <a:t>de identidade</a:t>
-            </a:r>
-          </a:p>
-        </p:txBody>
-      </p:sp>
-      <p:sp>
-        <p:nvSpPr>
-          <p:cNvPr id="18" name="AG escalar"/>
+              <a:t xml:space="preserve">de identidade</a:t>
+            </a:r>
+          </a:p>
+        </p:txBody>
+      </p:sp>
+      <p:sp>
+        <p:nvSpPr>
+          <p:cNvPr id="109" name="Cartão escalar"/>
           <p:cNvSpPr/>
           <p:nvPr/>
         </p:nvSpPr>
         <p:spPr>
           <a:xfrm>
-            <a:off x="10306050" y="3352800"/>
-            <a:ext cx="6953250" cy="4457700"/>
+            <a:off x="10309860" y="3017520"/>
+            <a:ext cx="6949440" cy="4846320"/>
           </a:xfrm>
           <a:prstGeom prst="roundRect">
             <a:avLst>
-              <a:gd name="adj" fmla="val 5128"/>
+              <a:gd name="adj" fmla="val 6000"/>
             </a:avLst>
           </a:prstGeom>
           <a:solidFill>
@@ -23816,14 +23546,14 @@
       </p:sp>
       <p:sp>
         <p:nvSpPr>
-          <p:cNvPr id="19" name="TextBox 18"/>
+          <p:cNvPr id="110" name="Título escalar"/>
           <p:cNvSpPr txBox="1"/>
           <p:nvPr/>
         </p:nvSpPr>
         <p:spPr>
           <a:xfrm>
-            <a:off x="10725150" y="3638550"/>
-            <a:ext cx="6115050" cy="476250"/>
+            <a:off x="10721340" y="3291840"/>
+            <a:ext cx="6126480" cy="548640"/>
           </a:xfrm>
           <a:prstGeom prst="rect">
             <a:avLst/>
@@ -23840,7 +23570,7 @@
               <a:buNone/>
             </a:pPr>
             <a:r>
-              <a:rPr lang="pt-BR" sz="3000" b="1" i="0" u="none" strike="noStrike" kern="1200" cap="none" spc="0" baseline="0">
+              <a:rPr lang="pt-BR" sz="3200" b="1" i="0" u="none" strike="noStrike" kern="1200" cap="none" spc="0" baseline="0">
                 <a:solidFill>
                   <a:srgbClr val="1B2740"/>
                 </a:solidFill>
@@ -23849,21 +23579,21 @@
                 <a:cs typeface="Montserrat Medium"/>
                 <a:sym typeface="Montserrat Medium"/>
               </a:rPr>
-              <a:t>AG escalar</a:t>
-            </a:r>
-          </a:p>
-        </p:txBody>
-      </p:sp>
-      <p:sp>
-        <p:nvSpPr>
-          <p:cNvPr id="20" name="TextBox 19"/>
+              <a:t xml:space="preserve">AG escalar</a:t>
+            </a:r>
+          </a:p>
+        </p:txBody>
+      </p:sp>
+      <p:sp>
+        <p:nvSpPr>
+          <p:cNvPr id="111" name="Sub escalar"/>
           <p:cNvSpPr txBox="1"/>
           <p:nvPr/>
         </p:nvSpPr>
         <p:spPr>
           <a:xfrm>
-            <a:off x="10725150" y="4133850"/>
-            <a:ext cx="6115050" cy="361950"/>
+            <a:off x="10721340" y="3840480"/>
+            <a:ext cx="6126480" cy="457200"/>
           </a:xfrm>
           <a:prstGeom prst="rect">
             <a:avLst/>
@@ -23880,7 +23610,7 @@
               <a:buNone/>
             </a:pPr>
             <a:r>
-              <a:rPr lang="pt-BR" sz="2200" b="0" i="0" u="none" strike="noStrike" kern="1200" cap="none" spc="0" baseline="0">
+              <a:rPr lang="pt-BR" sz="2800" b="0" i="0" u="none" strike="noStrike" kern="1200" cap="none" spc="0" baseline="0">
                 <a:solidFill>
                   <a:srgbClr val="5B6178"/>
                 </a:solidFill>
@@ -23889,21 +23619,21 @@
                 <a:cs typeface="Montserrat Medium"/>
                 <a:sym typeface="Montserrat Medium"/>
               </a:rPr>
-              <a:t>soma os dois objetivos</a:t>
-            </a:r>
-          </a:p>
-        </p:txBody>
-      </p:sp>
-      <p:sp>
-        <p:nvSpPr>
-          <p:cNvPr id="21" name="TextBox 20"/>
+              <a:t xml:space="preserve">soma os dois objetivos</a:t>
+            </a:r>
+          </a:p>
+        </p:txBody>
+      </p:sp>
+      <p:sp>
+        <p:nvSpPr>
+          <p:cNvPr id="112" name="Número escalar de 10 confrontos"/>
           <p:cNvSpPr txBox="1"/>
           <p:nvPr/>
         </p:nvSpPr>
         <p:spPr>
           <a:xfrm>
-            <a:off x="10725150" y="4610100"/>
-            <a:ext cx="2905125" cy="1943100"/>
+            <a:off x="10721340" y="4434840"/>
+            <a:ext cx="2103120" cy="1417320"/>
           </a:xfrm>
           <a:prstGeom prst="rect">
             <a:avLst/>
@@ -23911,7 +23641,7 @@
           <a:noFill/>
         </p:spPr>
         <p:txBody>
-          <a:bodyPr vert="horz" wrap="square" lIns="0" tIns="0" rIns="0" bIns="0" anchor="t" anchorCtr="0">
+          <a:bodyPr vert="horz" wrap="square" lIns="0" tIns="0" rIns="0" bIns="0" anchor="ctr" anchorCtr="0">
             <a:noAutofit/>
           </a:bodyPr>
           <a:lstStyle/>
@@ -23920,7 +23650,7 @@
               <a:buNone/>
             </a:pPr>
             <a:r>
-              <a:rPr lang="pt-BR" sz="12400" b="1" i="0" u="none" strike="noStrike" kern="1200" cap="none" spc="0" baseline="0">
+              <a:rPr lang="pt-BR" sz="10000" b="1" i="0" u="none" strike="noStrike" kern="1200" cap="none" spc="0" baseline="0">
                 <a:solidFill>
                   <a:srgbClr val="C8540F"/>
                 </a:solidFill>
@@ -23929,21 +23659,21 @@
                 <a:cs typeface="Montserrat Medium"/>
                 <a:sym typeface="Montserrat Medium"/>
               </a:rPr>
-              <a:t>10</a:t>
-            </a:r>
-          </a:p>
-        </p:txBody>
-      </p:sp>
-      <p:sp>
-        <p:nvSpPr>
-          <p:cNvPr id="22" name="TextBox 21"/>
+              <a:t xml:space="preserve">10</a:t>
+            </a:r>
+          </a:p>
+        </p:txBody>
+      </p:sp>
+      <p:sp>
+        <p:nvSpPr>
+          <p:cNvPr id="113" name="Legenda escalar de 10 confrontos"/>
           <p:cNvSpPr txBox="1"/>
           <p:nvPr/>
         </p:nvSpPr>
         <p:spPr>
           <a:xfrm>
-            <a:off x="10725150" y="6515100"/>
-            <a:ext cx="2905125" cy="800100"/>
+            <a:off x="12915900" y="4709160"/>
+            <a:ext cx="4023360" cy="914400"/>
           </a:xfrm>
           <a:prstGeom prst="rect">
             <a:avLst/>
@@ -23951,7 +23681,7 @@
           <a:noFill/>
         </p:spPr>
         <p:txBody>
-          <a:bodyPr vert="horz" wrap="square" lIns="0" tIns="0" rIns="0" bIns="0" anchor="t" anchorCtr="0">
+          <a:bodyPr vert="horz" wrap="square" lIns="0" tIns="0" rIns="0" bIns="0" anchor="ctr" anchorCtr="0">
             <a:noAutofit/>
           </a:bodyPr>
           <a:lstStyle/>
@@ -23960,7 +23690,7 @@
               <a:buNone/>
             </a:pPr>
             <a:r>
-              <a:rPr lang="pt-BR" sz="2400" b="0" i="0" u="none" strike="noStrike" kern="1200" cap="none" spc="0" baseline="0">
+              <a:rPr lang="pt-BR" sz="2800" b="0" i="0" u="none" strike="noStrike" kern="1200" cap="none" spc="0" baseline="0">
                 <a:solidFill>
                   <a:srgbClr val="1B2740"/>
                 </a:solidFill>
@@ -23969,7 +23699,7 @@
                 <a:cs typeface="Montserrat Medium"/>
                 <a:sym typeface="Montserrat Medium"/>
               </a:rPr>
-              <a:t>de 10 confrontos</a:t>
+              <a:t xml:space="preserve">de 10 confrontos</a:t>
             </a:r>
           </a:p>
           <a:p>
@@ -23977,7 +23707,7 @@
               <a:buNone/>
             </a:pPr>
             <a:r>
-              <a:rPr lang="pt-BR" sz="2400" b="0" i="0" u="none" strike="noStrike" kern="1200" cap="none" spc="0" baseline="0">
+              <a:rPr lang="pt-BR" sz="2800" b="0" i="0" u="none" strike="noStrike" kern="1200" cap="none" spc="0" baseline="0">
                 <a:solidFill>
                   <a:srgbClr val="1B2740"/>
                 </a:solidFill>
@@ -23986,21 +23716,21 @@
                 <a:cs typeface="Montserrat Medium"/>
                 <a:sym typeface="Montserrat Medium"/>
               </a:rPr>
-              <a:t>equilibrados</a:t>
-            </a:r>
-          </a:p>
-        </p:txBody>
-      </p:sp>
-      <p:sp>
-        <p:nvSpPr>
-          <p:cNvPr id="23" name="TextBox 22"/>
+              <a:t xml:space="preserve">equilibrados</a:t>
+            </a:r>
+          </a:p>
+        </p:txBody>
+      </p:sp>
+      <p:sp>
+        <p:nvSpPr>
+          <p:cNvPr id="114" name="Número escalar de 21 testes"/>
           <p:cNvSpPr txBox="1"/>
           <p:nvPr/>
         </p:nvSpPr>
         <p:spPr>
           <a:xfrm>
-            <a:off x="13935075" y="4610100"/>
-            <a:ext cx="2905125" cy="1943100"/>
+            <a:off x="10721340" y="6035040"/>
+            <a:ext cx="2103120" cy="1417320"/>
           </a:xfrm>
           <a:prstGeom prst="rect">
             <a:avLst/>
@@ -24008,7 +23738,7 @@
           <a:noFill/>
         </p:spPr>
         <p:txBody>
-          <a:bodyPr vert="horz" wrap="square" lIns="0" tIns="0" rIns="0" bIns="0" anchor="t" anchorCtr="0">
+          <a:bodyPr vert="horz" wrap="square" lIns="0" tIns="0" rIns="0" bIns="0" anchor="ctr" anchorCtr="0">
             <a:noAutofit/>
           </a:bodyPr>
           <a:lstStyle/>
@@ -24017,7 +23747,7 @@
               <a:buNone/>
             </a:pPr>
             <a:r>
-              <a:rPr lang="pt-BR" sz="12400" b="1" i="0" u="none" strike="noStrike" kern="1200" cap="none" spc="0" baseline="0">
+              <a:rPr lang="pt-BR" sz="10000" b="1" i="0" u="none" strike="noStrike" kern="1200" cap="none" spc="0" baseline="0">
                 <a:solidFill>
                   <a:srgbClr val="685BC7"/>
                 </a:solidFill>
@@ -24026,21 +23756,21 @@
                 <a:cs typeface="Montserrat Medium"/>
                 <a:sym typeface="Montserrat Medium"/>
               </a:rPr>
-              <a:t>7</a:t>
-            </a:r>
-          </a:p>
-        </p:txBody>
-      </p:sp>
-      <p:sp>
-        <p:nvSpPr>
-          <p:cNvPr id="24" name="TextBox 23"/>
+              <a:t xml:space="preserve">7</a:t>
+            </a:r>
+          </a:p>
+        </p:txBody>
+      </p:sp>
+      <p:sp>
+        <p:nvSpPr>
+          <p:cNvPr id="115" name="Legenda escalar de 21 testes"/>
           <p:cNvSpPr txBox="1"/>
           <p:nvPr/>
         </p:nvSpPr>
         <p:spPr>
           <a:xfrm>
-            <a:off x="13935075" y="6515100"/>
-            <a:ext cx="2905125" cy="800100"/>
+            <a:off x="12915900" y="6309360"/>
+            <a:ext cx="4023360" cy="914400"/>
           </a:xfrm>
           <a:prstGeom prst="rect">
             <a:avLst/>
@@ -24048,7 +23778,7 @@
           <a:noFill/>
         </p:spPr>
         <p:txBody>
-          <a:bodyPr vert="horz" wrap="square" lIns="0" tIns="0" rIns="0" bIns="0" anchor="t" anchorCtr="0">
+          <a:bodyPr vert="horz" wrap="square" lIns="0" tIns="0" rIns="0" bIns="0" anchor="ctr" anchorCtr="0">
             <a:noAutofit/>
           </a:bodyPr>
           <a:lstStyle/>
@@ -24057,7 +23787,7 @@
               <a:buNone/>
             </a:pPr>
             <a:r>
-              <a:rPr lang="pt-BR" sz="2400" b="0" i="0" u="none" strike="noStrike" kern="1200" cap="none" spc="0" baseline="0">
+              <a:rPr lang="pt-BR" sz="2800" b="0" i="0" u="none" strike="noStrike" kern="1200" cap="none" spc="0" baseline="0">
                 <a:solidFill>
                   <a:srgbClr val="1B2740"/>
                 </a:solidFill>
@@ -24066,7 +23796,7 @@
                 <a:cs typeface="Montserrat Medium"/>
                 <a:sym typeface="Montserrat Medium"/>
               </a:rPr>
-              <a:t>de 21 testes</a:t>
+              <a:t xml:space="preserve">de 21 testes</a:t>
             </a:r>
           </a:p>
           <a:p>
@@ -24074,7 +23804,7 @@
               <a:buNone/>
             </a:pPr>
             <a:r>
-              <a:rPr lang="pt-BR" sz="2400" b="0" i="0" u="none" strike="noStrike" kern="1200" cap="none" spc="0" baseline="0">
+              <a:rPr lang="pt-BR" sz="2800" b="0" i="0" u="none" strike="noStrike" kern="1200" cap="none" spc="0" baseline="0">
                 <a:solidFill>
                   <a:srgbClr val="1B2740"/>
                 </a:solidFill>
@@ -24083,26 +23813,26 @@
                 <a:cs typeface="Montserrat Medium"/>
                 <a:sym typeface="Montserrat Medium"/>
               </a:rPr>
-              <a:t>de identidade</a:t>
+              <a:t xml:space="preserve">de identidade</a:t>
             </a:r>
           </a:p>
         </p:txBody>
       </p:sp>
       <p:cxnSp>
         <p:nvCxnSpPr>
-          <p:cNvPr id="25" name="Connector 24"/>
+          <p:cNvPr id="116" name="Seta"/>
           <p:cNvCxnSpPr/>
           <p:nvPr/>
         </p:nvCxnSpPr>
         <p:spPr>
           <a:xfrm>
-            <a:off x="8248650" y="5581650"/>
-            <a:ext cx="1790700" cy="0"/>
+            <a:off x="8366760" y="5440680"/>
+            <a:ext cx="1554480" cy="0"/>
           </a:xfrm>
           <a:prstGeom prst="line">
             <a:avLst/>
           </a:prstGeom>
-          <a:ln w="47625">
+          <a:ln w="57150">
             <a:solidFill>
               <a:srgbClr val="1B2740"/>
             </a:solidFill>
@@ -24112,14 +23842,14 @@
       </p:cxnSp>
       <p:sp>
         <p:nvSpPr>
-          <p:cNvPr id="26" name="TextBox 25"/>
+          <p:cNvPr id="117" name="Nota"/>
           <p:cNvSpPr txBox="1"/>
           <p:nvPr/>
         </p:nvSpPr>
         <p:spPr>
           <a:xfrm>
-            <a:off x="1028700" y="8077200"/>
-            <a:ext cx="16230600" cy="342900"/>
+            <a:off x="1028700" y="8138160"/>
+            <a:ext cx="16230600" cy="502920"/>
           </a:xfrm>
           <a:prstGeom prst="rect">
             <a:avLst/>
@@ -24136,7 +23866,7 @@
               <a:buNone/>
             </a:pPr>
             <a:r>
-              <a:rPr lang="pt-BR" sz="2000" b="0" i="0" u="none" strike="noStrike" kern="1200" cap="none" spc="0" baseline="0">
+              <a:rPr lang="pt-BR" sz="2800" b="0" i="0" u="none" strike="noStrike" kern="1200" cap="none" spc="0" baseline="0">
                 <a:solidFill>
                   <a:srgbClr val="5B6178"/>
                 </a:solidFill>
@@ -24145,7 +23875,7 @@
                 <a:cs typeface="Montserrat Medium"/>
                 <a:sym typeface="Montserrat Medium"/>
               </a:rPr>
-              <a:t>Confronto equilibrado: taxa de vitória entre 40% e 60%</a:t>
+              <a:t xml:space="preserve">Confronto equilibrado: taxa de vitória entre 40% e 60%</a:t>
             </a:r>
           </a:p>
         </p:txBody>
@@ -25099,8 +24829,8 @@
         </p:blipFill>
         <p:spPr>
           <a:xfrm>
-            <a:off x="971550" y="2971800"/>
-            <a:ext cx="8382000" cy="5858387"/>
+            <a:off x="777240" y="2788920"/>
+            <a:ext cx="9418320" cy="6583680"/>
           </a:xfrm>
           <a:prstGeom prst="rect">
             <a:avLst/>
@@ -25109,14 +24839,43 @@
       </p:pic>
       <p:sp>
         <p:nvSpPr>
-          <p:cNvPr id="12" name="TextBox 11"/>
+          <p:cNvPr id="101" name="Cor equilíbrio"/>
+          <p:cNvSpPr/>
+          <p:nvPr/>
+        </p:nvSpPr>
+        <p:spPr>
+          <a:xfrm>
+            <a:off x="10561320" y="2990088"/>
+            <a:ext cx="274320" cy="274320"/>
+          </a:xfrm>
+          <a:prstGeom prst="rect">
+            <a:avLst/>
+          </a:prstGeom>
+          <a:solidFill>
+            <a:srgbClr val="C8540F"/>
+          </a:solidFill>
+          <a:ln>
+            <a:noFill/>
+          </a:ln>
+        </p:spPr>
+        <p:txBody>
+          <a:bodyPr rtlCol="0" anchor="ctr"/>
+          <a:lstStyle/>
+          <a:p>
+            <a:pPr algn="ctr"/>
+          </a:p>
+        </p:txBody>
+      </p:sp>
+      <p:sp>
+        <p:nvSpPr>
+          <p:cNvPr id="102" name="Legenda equilíbrio"/>
           <p:cNvSpPr txBox="1"/>
           <p:nvPr/>
         </p:nvSpPr>
         <p:spPr>
           <a:xfrm>
-            <a:off x="1028700" y="8915400"/>
-            <a:ext cx="8382000" cy="342900"/>
+            <a:off x="11018520" y="2880360"/>
+            <a:ext cx="6263640" cy="457200"/>
           </a:xfrm>
           <a:prstGeom prst="rect">
             <a:avLst/>
@@ -25133,30 +24892,59 @@
               <a:buNone/>
             </a:pPr>
             <a:r>
-              <a:rPr lang="pt-BR" sz="2000" b="0" i="0" u="none" strike="noStrike" kern="1200" cap="none" spc="0" baseline="0">
-                <a:solidFill>
-                  <a:srgbClr val="5B6178"/>
+              <a:rPr lang="pt-BR" sz="2800" b="0" i="0" u="none" strike="noStrike" kern="1200" cap="none" spc="0" baseline="0">
+                <a:solidFill>
+                  <a:srgbClr val="1B2740"/>
                 </a:solidFill>
                 <a:latin typeface="Montserrat Medium"/>
                 <a:ea typeface="Montserrat Medium"/>
                 <a:cs typeface="Montserrat Medium"/>
                 <a:sym typeface="Montserrat Medium"/>
               </a:rPr>
-              <a:t>Cada ponto é um elenco da fronteira do NSGA-II</a:t>
-            </a:r>
-          </a:p>
-        </p:txBody>
-      </p:sp>
-      <p:sp>
-        <p:nvSpPr>
-          <p:cNvPr id="13" name="TextBox 12"/>
+              <a:t xml:space="preserve">confrontos equilibrados</a:t>
+            </a:r>
+          </a:p>
+        </p:txBody>
+      </p:sp>
+      <p:sp>
+        <p:nvSpPr>
+          <p:cNvPr id="103" name="Cor identidade"/>
+          <p:cNvSpPr/>
+          <p:nvPr/>
+        </p:nvSpPr>
+        <p:spPr>
+          <a:xfrm>
+            <a:off x="10561320" y="3493008"/>
+            <a:ext cx="274320" cy="274320"/>
+          </a:xfrm>
+          <a:prstGeom prst="rect">
+            <a:avLst/>
+          </a:prstGeom>
+          <a:solidFill>
+            <a:srgbClr val="685BC7"/>
+          </a:solidFill>
+          <a:ln>
+            <a:noFill/>
+          </a:ln>
+        </p:spPr>
+        <p:txBody>
+          <a:bodyPr rtlCol="0" anchor="ctr"/>
+          <a:lstStyle/>
+          <a:p>
+            <a:pPr algn="ctr"/>
+          </a:p>
+        </p:txBody>
+      </p:sp>
+      <p:sp>
+        <p:nvSpPr>
+          <p:cNvPr id="104" name="Legenda identidade"/>
           <p:cNvSpPr txBox="1"/>
           <p:nvPr/>
         </p:nvSpPr>
         <p:spPr>
           <a:xfrm>
-            <a:off x="13601700" y="3028950"/>
-            <a:ext cx="1828800" cy="990600"/>
+            <a:off x="11018520" y="3383280"/>
+            <a:ext cx="6263640" cy="457200"/>
           </a:xfrm>
           <a:prstGeom prst="rect">
             <a:avLst/>
@@ -25169,112 +24957,38 @@
           </a:bodyPr>
           <a:lstStyle/>
           <a:p>
-            <a:pPr marL="0" indent="0" algn="ctr">
+            <a:pPr marL="0" indent="0" algn="l">
               <a:buNone/>
             </a:pPr>
             <a:r>
-              <a:rPr lang="pt-BR" sz="2000" b="1" i="0" u="none" strike="noStrike" kern="1200" cap="none" spc="0" baseline="0">
-                <a:solidFill>
-                  <a:srgbClr val="C8540F"/>
+              <a:rPr lang="pt-BR" sz="2800" b="0" i="0" u="none" strike="noStrike" kern="1200" cap="none" spc="0" baseline="0">
+                <a:solidFill>
+                  <a:srgbClr val="1B2740"/>
                 </a:solidFill>
                 <a:latin typeface="Montserrat Medium"/>
                 <a:ea typeface="Montserrat Medium"/>
                 <a:cs typeface="Montserrat Medium"/>
                 <a:sym typeface="Montserrat Medium"/>
               </a:rPr>
-              <a:t>confrontos equilibrados</a:t>
-            </a:r>
-          </a:p>
-          <a:p>
-            <a:pPr marL="0" indent="0" algn="ctr">
-              <a:buNone/>
-            </a:pPr>
-            <a:r>
-              <a:rPr lang="pt-BR" sz="2000" b="0" i="0" u="none" strike="noStrike" kern="1200" cap="none" spc="0" baseline="0">
-                <a:solidFill>
-                  <a:srgbClr val="5B6178"/>
-                </a:solidFill>
-                <a:latin typeface="Montserrat Medium"/>
-                <a:ea typeface="Montserrat Medium"/>
-                <a:cs typeface="Montserrat Medium"/>
-                <a:sym typeface="Montserrat Medium"/>
-              </a:rPr>
-              <a:t>(de 10)</a:t>
-            </a:r>
-          </a:p>
-        </p:txBody>
-      </p:sp>
-      <p:sp>
-        <p:nvSpPr>
-          <p:cNvPr id="14" name="TextBox 13"/>
-          <p:cNvSpPr txBox="1"/>
-          <p:nvPr/>
-        </p:nvSpPr>
-        <p:spPr>
-          <a:xfrm>
-            <a:off x="15430500" y="3028950"/>
-            <a:ext cx="1828800" cy="990600"/>
-          </a:xfrm>
-          <a:prstGeom prst="rect">
-            <a:avLst/>
-          </a:prstGeom>
-          <a:noFill/>
-        </p:spPr>
-        <p:txBody>
-          <a:bodyPr vert="horz" wrap="square" lIns="0" tIns="0" rIns="0" bIns="0" anchor="t" anchorCtr="0">
-            <a:noAutofit/>
-          </a:bodyPr>
-          <a:lstStyle/>
-          <a:p>
-            <a:pPr marL="0" indent="0" algn="ctr">
-              <a:buNone/>
-            </a:pPr>
-            <a:r>
-              <a:rPr lang="pt-BR" sz="2000" b="1" i="0" u="none" strike="noStrike" kern="1200" cap="none" spc="0" baseline="0">
-                <a:solidFill>
-                  <a:srgbClr val="685BC7"/>
-                </a:solidFill>
-                <a:latin typeface="Montserrat Medium"/>
-                <a:ea typeface="Montserrat Medium"/>
-                <a:cs typeface="Montserrat Medium"/>
-                <a:sym typeface="Montserrat Medium"/>
-              </a:rPr>
-              <a:t>testes de identidade</a:t>
-            </a:r>
-          </a:p>
-          <a:p>
-            <a:pPr marL="0" indent="0" algn="ctr">
-              <a:buNone/>
-            </a:pPr>
-            <a:r>
-              <a:rPr lang="pt-BR" sz="2000" b="0" i="0" u="none" strike="noStrike" kern="1200" cap="none" spc="0" baseline="0">
-                <a:solidFill>
-                  <a:srgbClr val="5B6178"/>
-                </a:solidFill>
-                <a:latin typeface="Montserrat Medium"/>
-                <a:ea typeface="Montserrat Medium"/>
-                <a:cs typeface="Montserrat Medium"/>
-                <a:sym typeface="Montserrat Medium"/>
-              </a:rPr>
-              <a:t>(de 21)</a:t>
-            </a:r>
-          </a:p>
-        </p:txBody>
-      </p:sp>
-      <p:sp>
-        <p:nvSpPr>
-          <p:cNvPr id="15" name="Linha Canônico"/>
+              <a:t xml:space="preserve">testes de identidade</a:t>
+            </a:r>
+          </a:p>
+        </p:txBody>
+      </p:sp>
+      <p:sp>
+        <p:nvSpPr>
+          <p:cNvPr id="105" name="Linha Canônico"/>
           <p:cNvSpPr/>
           <p:nvPr/>
         </p:nvSpPr>
         <p:spPr>
           <a:xfrm>
-            <a:off x="9906000" y="4152900"/>
-            <a:ext cx="7353300" cy="1066800"/>
+            <a:off x="10561320" y="4434840"/>
+            <a:ext cx="6697980" cy="1188720"/>
           </a:xfrm>
           <a:prstGeom prst="roundRect">
             <a:avLst>
-              <a:gd name="adj" fmla="val 14285"/>
+              <a:gd name="adj" fmla="val 12000"/>
             </a:avLst>
           </a:prstGeom>
           <a:solidFill>
@@ -25294,14 +25008,14 @@
       </p:sp>
       <p:sp>
         <p:nvSpPr>
-          <p:cNvPr id="16" name="Oval 15"/>
+          <p:cNvPr id="106" name="Marcador Canônico"/>
           <p:cNvSpPr/>
           <p:nvPr/>
         </p:nvSpPr>
         <p:spPr>
           <a:xfrm>
-            <a:off x="10144125" y="4543425"/>
-            <a:ext cx="285750" cy="285750"/>
+            <a:off x="10835640" y="4846320"/>
+            <a:ext cx="365760" cy="365760"/>
           </a:xfrm>
           <a:prstGeom prst="ellipse">
             <a:avLst/>
@@ -25323,14 +25037,14 @@
       </p:sp>
       <p:sp>
         <p:nvSpPr>
-          <p:cNvPr id="17" name="TextBox 16"/>
+          <p:cNvPr id="107" name="Rótulo Canônico"/>
           <p:cNvSpPr txBox="1"/>
           <p:nvPr/>
         </p:nvSpPr>
         <p:spPr>
           <a:xfrm>
-            <a:off x="10610850" y="4152900"/>
-            <a:ext cx="2933700" cy="1066800"/>
+            <a:off x="11384280" y="4434840"/>
+            <a:ext cx="2926080" cy="1188720"/>
           </a:xfrm>
           <a:prstGeom prst="rect">
             <a:avLst/>
@@ -25344,10 +25058,13 @@
           <a:lstStyle/>
           <a:p>
             <a:pPr marL="0" indent="0" algn="l">
+              <a:lnSpc>
+                <a:spcPct val="90000"/>
+              </a:lnSpc>
               <a:buNone/>
             </a:pPr>
             <a:r>
-              <a:rPr lang="pt-BR" sz="2400" b="1" i="0" u="none" strike="noStrike" kern="1200" cap="none" spc="0" baseline="0">
+              <a:rPr lang="pt-BR" sz="3000" b="1" i="0" u="none" strike="noStrike" kern="1200" cap="none" spc="0" baseline="0">
                 <a:solidFill>
                   <a:srgbClr val="1B2740"/>
                 </a:solidFill>
@@ -25356,21 +25073,21 @@
                 <a:cs typeface="Montserrat Medium"/>
                 <a:sym typeface="Montserrat Medium"/>
               </a:rPr>
-              <a:t>Canônico</a:t>
-            </a:r>
-          </a:p>
-        </p:txBody>
-      </p:sp>
-      <p:sp>
-        <p:nvSpPr>
-          <p:cNvPr id="18" name="TextBox 17"/>
+              <a:t xml:space="preserve">Canônico</a:t>
+            </a:r>
+          </a:p>
+        </p:txBody>
+      </p:sp>
+      <p:sp>
+        <p:nvSpPr>
+          <p:cNvPr id="108" name="Equilíbrio Canônico"/>
           <p:cNvSpPr txBox="1"/>
           <p:nvPr/>
         </p:nvSpPr>
         <p:spPr>
           <a:xfrm>
-            <a:off x="13601700" y="4152900"/>
-            <a:ext cx="1828800" cy="1066800"/>
+            <a:off x="14310360" y="4434840"/>
+            <a:ext cx="1280160" cy="1188720"/>
           </a:xfrm>
           <a:prstGeom prst="rect">
             <a:avLst/>
@@ -25387,7 +25104,7 @@
               <a:buNone/>
             </a:pPr>
             <a:r>
-              <a:rPr lang="pt-BR" sz="4600" b="1" i="0" u="none" strike="noStrike" kern="1200" cap="none" spc="0" baseline="0">
+              <a:rPr lang="pt-BR" sz="4800" b="1" i="0" u="none" strike="noStrike" kern="1200" cap="none" spc="0" baseline="0">
                 <a:solidFill>
                   <a:srgbClr val="C8540F"/>
                 </a:solidFill>
@@ -25396,21 +25113,21 @@
                 <a:cs typeface="Montserrat Medium"/>
                 <a:sym typeface="Montserrat Medium"/>
               </a:rPr>
-              <a:t>0</a:t>
-            </a:r>
-          </a:p>
-        </p:txBody>
-      </p:sp>
-      <p:sp>
-        <p:nvSpPr>
-          <p:cNvPr id="19" name="TextBox 18"/>
+              <a:t xml:space="preserve">0</a:t>
+            </a:r>
+          </a:p>
+        </p:txBody>
+      </p:sp>
+      <p:sp>
+        <p:nvSpPr>
+          <p:cNvPr id="109" name="Identidade Canônico"/>
           <p:cNvSpPr txBox="1"/>
           <p:nvPr/>
         </p:nvSpPr>
         <p:spPr>
           <a:xfrm>
-            <a:off x="15430500" y="4152900"/>
-            <a:ext cx="1828800" cy="1066800"/>
+            <a:off x="15681960" y="4434840"/>
+            <a:ext cx="1463040" cy="1188720"/>
           </a:xfrm>
           <a:prstGeom prst="rect">
             <a:avLst/>
@@ -25427,7 +25144,7 @@
               <a:buNone/>
             </a:pPr>
             <a:r>
-              <a:rPr lang="pt-BR" sz="4600" b="1" i="0" u="none" strike="noStrike" kern="1200" cap="none" spc="0" baseline="0">
+              <a:rPr lang="pt-BR" sz="4800" b="1" i="0" u="none" strike="noStrike" kern="1200" cap="none" spc="0" baseline="0">
                 <a:solidFill>
                   <a:srgbClr val="685BC7"/>
                 </a:solidFill>
@@ -25436,25 +25153,25 @@
                 <a:cs typeface="Montserrat Medium"/>
                 <a:sym typeface="Montserrat Medium"/>
               </a:rPr>
-              <a:t>21</a:t>
-            </a:r>
-          </a:p>
-        </p:txBody>
-      </p:sp>
-      <p:sp>
-        <p:nvSpPr>
-          <p:cNvPr id="20" name="Linha Joelho"/>
+              <a:t xml:space="preserve">21</a:t>
+            </a:r>
+          </a:p>
+        </p:txBody>
+      </p:sp>
+      <p:sp>
+        <p:nvSpPr>
+          <p:cNvPr id="110" name="Linha Joelho"/>
           <p:cNvSpPr/>
           <p:nvPr/>
         </p:nvSpPr>
         <p:spPr>
           <a:xfrm>
-            <a:off x="9906000" y="5334000"/>
-            <a:ext cx="7353300" cy="1066800"/>
+            <a:off x="10561320" y="5760720"/>
+            <a:ext cx="6697980" cy="1188720"/>
           </a:xfrm>
           <a:prstGeom prst="roundRect">
             <a:avLst>
-              <a:gd name="adj" fmla="val 14285"/>
+              <a:gd name="adj" fmla="val 12000"/>
             </a:avLst>
           </a:prstGeom>
           <a:solidFill>
@@ -25476,14 +25193,14 @@
       </p:sp>
       <p:sp>
         <p:nvSpPr>
-          <p:cNvPr id="21" name="Isosceles Triangle 20"/>
+          <p:cNvPr id="111" name="Marcador Joelho"/>
           <p:cNvSpPr/>
           <p:nvPr/>
         </p:nvSpPr>
         <p:spPr>
           <a:xfrm>
-            <a:off x="10144125" y="5724525"/>
-            <a:ext cx="285750" cy="285750"/>
+            <a:off x="10835640" y="6172200"/>
+            <a:ext cx="365760" cy="365760"/>
           </a:xfrm>
           <a:prstGeom prst="triangle">
             <a:avLst/>
@@ -25505,14 +25222,14 @@
       </p:sp>
       <p:sp>
         <p:nvSpPr>
-          <p:cNvPr id="22" name="TextBox 21"/>
+          <p:cNvPr id="112" name="Rótulo Joelho"/>
           <p:cNvSpPr txBox="1"/>
           <p:nvPr/>
         </p:nvSpPr>
         <p:spPr>
           <a:xfrm>
-            <a:off x="10610850" y="5334000"/>
-            <a:ext cx="2933700" cy="1066800"/>
+            <a:off x="11384280" y="5760720"/>
+            <a:ext cx="2926080" cy="1188720"/>
           </a:xfrm>
           <a:prstGeom prst="rect">
             <a:avLst/>
@@ -25526,10 +25243,13 @@
           <a:lstStyle/>
           <a:p>
             <a:pPr marL="0" indent="0" algn="l">
+              <a:lnSpc>
+                <a:spcPct val="90000"/>
+              </a:lnSpc>
               <a:buNone/>
             </a:pPr>
             <a:r>
-              <a:rPr lang="pt-BR" sz="2400" b="1" i="0" u="none" strike="noStrike" kern="1200" cap="none" spc="0" baseline="0">
+              <a:rPr lang="pt-BR" sz="3000" b="1" i="0" u="none" strike="noStrike" kern="1200" cap="none" spc="0" baseline="0">
                 <a:solidFill>
                   <a:srgbClr val="1B2740"/>
                 </a:solidFill>
@@ -25538,21 +25258,21 @@
                 <a:cs typeface="Montserrat Medium"/>
                 <a:sym typeface="Montserrat Medium"/>
               </a:rPr>
-              <a:t>Joelho</a:t>
-            </a:r>
-          </a:p>
-        </p:txBody>
-      </p:sp>
-      <p:sp>
-        <p:nvSpPr>
-          <p:cNvPr id="23" name="TextBox 22"/>
+              <a:t xml:space="preserve">Joelho</a:t>
+            </a:r>
+          </a:p>
+        </p:txBody>
+      </p:sp>
+      <p:sp>
+        <p:nvSpPr>
+          <p:cNvPr id="113" name="Equilíbrio Joelho"/>
           <p:cNvSpPr txBox="1"/>
           <p:nvPr/>
         </p:nvSpPr>
         <p:spPr>
           <a:xfrm>
-            <a:off x="13601700" y="5334000"/>
-            <a:ext cx="1828800" cy="1066800"/>
+            <a:off x="14310360" y="5760720"/>
+            <a:ext cx="1280160" cy="1188720"/>
           </a:xfrm>
           <a:prstGeom prst="rect">
             <a:avLst/>
@@ -25569,7 +25289,7 @@
               <a:buNone/>
             </a:pPr>
             <a:r>
-              <a:rPr lang="pt-BR" sz="4600" b="1" i="0" u="none" strike="noStrike" kern="1200" cap="none" spc="0" baseline="0">
+              <a:rPr lang="pt-BR" sz="4800" b="1" i="0" u="none" strike="noStrike" kern="1200" cap="none" spc="0" baseline="0">
                 <a:solidFill>
                   <a:srgbClr val="C8540F"/>
                 </a:solidFill>
@@ -25578,21 +25298,21 @@
                 <a:cs typeface="Montserrat Medium"/>
                 <a:sym typeface="Montserrat Medium"/>
               </a:rPr>
-              <a:t>2</a:t>
-            </a:r>
-          </a:p>
-        </p:txBody>
-      </p:sp>
-      <p:sp>
-        <p:nvSpPr>
-          <p:cNvPr id="24" name="TextBox 23"/>
+              <a:t xml:space="preserve">2</a:t>
+            </a:r>
+          </a:p>
+        </p:txBody>
+      </p:sp>
+      <p:sp>
+        <p:nvSpPr>
+          <p:cNvPr id="114" name="Identidade Joelho"/>
           <p:cNvSpPr txBox="1"/>
           <p:nvPr/>
         </p:nvSpPr>
         <p:spPr>
           <a:xfrm>
-            <a:off x="15430500" y="5334000"/>
-            <a:ext cx="1828800" cy="1066800"/>
+            <a:off x="15681960" y="5760720"/>
+            <a:ext cx="1463040" cy="1188720"/>
           </a:xfrm>
           <a:prstGeom prst="rect">
             <a:avLst/>
@@ -25609,7 +25329,7 @@
               <a:buNone/>
             </a:pPr>
             <a:r>
-              <a:rPr lang="pt-BR" sz="4600" b="1" i="0" u="none" strike="noStrike" kern="1200" cap="none" spc="0" baseline="0">
+              <a:rPr lang="pt-BR" sz="4800" b="1" i="0" u="none" strike="noStrike" kern="1200" cap="none" spc="0" baseline="0">
                 <a:solidFill>
                   <a:srgbClr val="685BC7"/>
                 </a:solidFill>
@@ -25618,25 +25338,25 @@
                 <a:cs typeface="Montserrat Medium"/>
                 <a:sym typeface="Montserrat Medium"/>
               </a:rPr>
-              <a:t>20</a:t>
-            </a:r>
-          </a:p>
-        </p:txBody>
-      </p:sp>
-      <p:sp>
-        <p:nvSpPr>
-          <p:cNvPr id="25" name="Linha Mais equilibrado"/>
+              <a:t xml:space="preserve">20</a:t>
+            </a:r>
+          </a:p>
+        </p:txBody>
+      </p:sp>
+      <p:sp>
+        <p:nvSpPr>
+          <p:cNvPr id="115" name="Linha Mais equilibrado"/>
           <p:cNvSpPr/>
           <p:nvPr/>
         </p:nvSpPr>
         <p:spPr>
           <a:xfrm>
-            <a:off x="9906000" y="6515100"/>
-            <a:ext cx="7353300" cy="1066800"/>
+            <a:off x="10561320" y="7086600"/>
+            <a:ext cx="6697980" cy="1188720"/>
           </a:xfrm>
           <a:prstGeom prst="roundRect">
             <a:avLst>
-              <a:gd name="adj" fmla="val 14285"/>
+              <a:gd name="adj" fmla="val 12000"/>
             </a:avLst>
           </a:prstGeom>
           <a:solidFill>
@@ -25656,14 +25376,14 @@
       </p:sp>
       <p:sp>
         <p:nvSpPr>
-          <p:cNvPr id="26" name="Rectangle 25"/>
+          <p:cNvPr id="116" name="Marcador Mais equilibrado"/>
           <p:cNvSpPr/>
           <p:nvPr/>
         </p:nvSpPr>
         <p:spPr>
           <a:xfrm>
-            <a:off x="10144125" y="6905625"/>
-            <a:ext cx="285750" cy="285750"/>
+            <a:off x="10835640" y="7498080"/>
+            <a:ext cx="365760" cy="365760"/>
           </a:xfrm>
           <a:prstGeom prst="rect">
             <a:avLst/>
@@ -25685,14 +25405,14 @@
       </p:sp>
       <p:sp>
         <p:nvSpPr>
-          <p:cNvPr id="27" name="TextBox 26"/>
+          <p:cNvPr id="117" name="Rótulo Mais equilibrado"/>
           <p:cNvSpPr txBox="1"/>
           <p:nvPr/>
         </p:nvSpPr>
         <p:spPr>
           <a:xfrm>
-            <a:off x="10610850" y="6515100"/>
-            <a:ext cx="2933700" cy="1066800"/>
+            <a:off x="11384280" y="7086600"/>
+            <a:ext cx="2926080" cy="1188720"/>
           </a:xfrm>
           <a:prstGeom prst="rect">
             <a:avLst/>
@@ -25706,10 +25426,13 @@
           <a:lstStyle/>
           <a:p>
             <a:pPr marL="0" indent="0" algn="l">
+              <a:lnSpc>
+                <a:spcPct val="90000"/>
+              </a:lnSpc>
               <a:buNone/>
             </a:pPr>
             <a:r>
-              <a:rPr lang="pt-BR" sz="2400" b="1" i="0" u="none" strike="noStrike" kern="1200" cap="none" spc="0" baseline="0">
+              <a:rPr lang="pt-BR" sz="3000" b="1" i="0" u="none" strike="noStrike" kern="1200" cap="none" spc="0" baseline="0">
                 <a:solidFill>
                   <a:srgbClr val="1B2740"/>
                 </a:solidFill>
@@ -25718,21 +25441,21 @@
                 <a:cs typeface="Montserrat Medium"/>
                 <a:sym typeface="Montserrat Medium"/>
               </a:rPr>
-              <a:t>Mais equilibrado</a:t>
-            </a:r>
-          </a:p>
-        </p:txBody>
-      </p:sp>
-      <p:sp>
-        <p:nvSpPr>
-          <p:cNvPr id="28" name="TextBox 27"/>
+              <a:t xml:space="preserve">Mais equilibrado</a:t>
+            </a:r>
+          </a:p>
+        </p:txBody>
+      </p:sp>
+      <p:sp>
+        <p:nvSpPr>
+          <p:cNvPr id="118" name="Equilíbrio Mais equilibrado"/>
           <p:cNvSpPr txBox="1"/>
           <p:nvPr/>
         </p:nvSpPr>
         <p:spPr>
           <a:xfrm>
-            <a:off x="13601700" y="6515100"/>
-            <a:ext cx="1828800" cy="1066800"/>
+            <a:off x="14310360" y="7086600"/>
+            <a:ext cx="1280160" cy="1188720"/>
           </a:xfrm>
           <a:prstGeom prst="rect">
             <a:avLst/>
@@ -25749,7 +25472,7 @@
               <a:buNone/>
             </a:pPr>
             <a:r>
-              <a:rPr lang="pt-BR" sz="4600" b="1" i="0" u="none" strike="noStrike" kern="1200" cap="none" spc="0" baseline="0">
+              <a:rPr lang="pt-BR" sz="4800" b="1" i="0" u="none" strike="noStrike" kern="1200" cap="none" spc="0" baseline="0">
                 <a:solidFill>
                   <a:srgbClr val="C8540F"/>
                 </a:solidFill>
@@ -25758,21 +25481,21 @@
                 <a:cs typeface="Montserrat Medium"/>
                 <a:sym typeface="Montserrat Medium"/>
               </a:rPr>
-              <a:t>9</a:t>
-            </a:r>
-          </a:p>
-        </p:txBody>
-      </p:sp>
-      <p:sp>
-        <p:nvSpPr>
-          <p:cNvPr id="29" name="TextBox 28"/>
+              <a:t xml:space="preserve">9</a:t>
+            </a:r>
+          </a:p>
+        </p:txBody>
+      </p:sp>
+      <p:sp>
+        <p:nvSpPr>
+          <p:cNvPr id="119" name="Identidade Mais equilibrado"/>
           <p:cNvSpPr txBox="1"/>
           <p:nvPr/>
         </p:nvSpPr>
         <p:spPr>
           <a:xfrm>
-            <a:off x="15430500" y="6515100"/>
-            <a:ext cx="1828800" cy="1066800"/>
+            <a:off x="15681960" y="7086600"/>
+            <a:ext cx="1463040" cy="1188720"/>
           </a:xfrm>
           <a:prstGeom prst="rect">
             <a:avLst/>
@@ -25789,7 +25512,7 @@
               <a:buNone/>
             </a:pPr>
             <a:r>
-              <a:rPr lang="pt-BR" sz="4600" b="1" i="0" u="none" strike="noStrike" kern="1200" cap="none" spc="0" baseline="0">
+              <a:rPr lang="pt-BR" sz="4800" b="1" i="0" u="none" strike="noStrike" kern="1200" cap="none" spc="0" baseline="0">
                 <a:solidFill>
                   <a:srgbClr val="685BC7"/>
                 </a:solidFill>
@@ -25798,81 +25521,21 @@
                 <a:cs typeface="Montserrat Medium"/>
                 <a:sym typeface="Montserrat Medium"/>
               </a:rPr>
-              <a:t>13</a:t>
-            </a:r>
-          </a:p>
-        </p:txBody>
-      </p:sp>
-      <p:sp>
-        <p:nvSpPr>
-          <p:cNvPr id="30" name="Linha AG escalar"/>
-          <p:cNvSpPr/>
-          <p:nvPr/>
-        </p:nvSpPr>
-        <p:spPr>
-          <a:xfrm>
-            <a:off x="9906000" y="7696200"/>
-            <a:ext cx="7353300" cy="1066800"/>
-          </a:xfrm>
-          <a:prstGeom prst="roundRect">
-            <a:avLst>
-              <a:gd name="adj" fmla="val 14285"/>
-            </a:avLst>
-          </a:prstGeom>
-          <a:solidFill>
-            <a:srgbClr val="F4F4F9"/>
-          </a:solidFill>
-          <a:ln>
-            <a:noFill/>
-          </a:ln>
-        </p:spPr>
-        <p:txBody>
-          <a:bodyPr rtlCol="0" anchor="ctr"/>
-          <a:lstStyle/>
-          <a:p>
-            <a:pPr algn="ctr"/>
-          </a:p>
-        </p:txBody>
-      </p:sp>
-      <p:sp>
-        <p:nvSpPr>
-          <p:cNvPr id="31" name="Oval 30"/>
-          <p:cNvSpPr/>
-          <p:nvPr/>
-        </p:nvSpPr>
-        <p:spPr>
-          <a:xfrm>
-            <a:off x="10144125" y="8086725"/>
-            <a:ext cx="285750" cy="285750"/>
-          </a:xfrm>
-          <a:prstGeom prst="ellipse">
-            <a:avLst/>
-          </a:prstGeom>
-          <a:noFill/>
-          <a:ln w="28575">
-            <a:solidFill>
-              <a:srgbClr val="1B2740"/>
-            </a:solidFill>
-          </a:ln>
-        </p:spPr>
-        <p:txBody>
-          <a:bodyPr rtlCol="0" anchor="ctr"/>
-          <a:lstStyle/>
-          <a:p>
-            <a:pPr algn="ctr"/>
-          </a:p>
-        </p:txBody>
-      </p:sp>
-      <p:sp>
-        <p:nvSpPr>
-          <p:cNvPr id="32" name="TextBox 31"/>
+              <a:t xml:space="preserve">13</a:t>
+            </a:r>
+          </a:p>
+        </p:txBody>
+      </p:sp>
+      <p:sp>
+        <p:nvSpPr>
+          <p:cNvPr id="120" name="Denominador equilíbrio"/>
           <p:cNvSpPr txBox="1"/>
           <p:nvPr/>
         </p:nvSpPr>
         <p:spPr>
           <a:xfrm>
-            <a:off x="10610850" y="7867650"/>
-            <a:ext cx="2933700" cy="400050"/>
+            <a:off x="14310360" y="3931920"/>
+            <a:ext cx="1280160" cy="457200"/>
           </a:xfrm>
           <a:prstGeom prst="rect">
             <a:avLst/>
@@ -25885,34 +25548,34 @@
           </a:bodyPr>
           <a:lstStyle/>
           <a:p>
-            <a:pPr marL="0" indent="0" algn="l">
+            <a:pPr marL="0" indent="0" algn="ctr">
               <a:buNone/>
             </a:pPr>
             <a:r>
-              <a:rPr lang="pt-BR" sz="2400" b="1" i="0" u="none" strike="noStrike" kern="1200" cap="none" spc="0" baseline="0">
-                <a:solidFill>
-                  <a:srgbClr val="1B2740"/>
+              <a:rPr lang="pt-BR" sz="2800" b="1" i="0" u="none" strike="noStrike" kern="1200" cap="none" spc="0" baseline="0">
+                <a:solidFill>
+                  <a:srgbClr val="C8540F"/>
                 </a:solidFill>
                 <a:latin typeface="Montserrat Medium"/>
                 <a:ea typeface="Montserrat Medium"/>
                 <a:cs typeface="Montserrat Medium"/>
                 <a:sym typeface="Montserrat Medium"/>
               </a:rPr>
-              <a:t>AG escalar</a:t>
-            </a:r>
-          </a:p>
-        </p:txBody>
-      </p:sp>
-      <p:sp>
-        <p:nvSpPr>
-          <p:cNvPr id="33" name="TextBox 32"/>
+              <a:t xml:space="preserve">de 10</a:t>
+            </a:r>
+          </a:p>
+        </p:txBody>
+      </p:sp>
+      <p:sp>
+        <p:nvSpPr>
+          <p:cNvPr id="121" name="Denominador identidade"/>
           <p:cNvSpPr txBox="1"/>
           <p:nvPr/>
         </p:nvSpPr>
         <p:spPr>
           <a:xfrm>
-            <a:off x="10610850" y="8267700"/>
-            <a:ext cx="2933700" cy="342900"/>
+            <a:off x="15681960" y="3931920"/>
+            <a:ext cx="1463040" cy="457200"/>
           </a:xfrm>
           <a:prstGeom prst="rect">
             <a:avLst/>
@@ -25925,34 +25588,34 @@
           </a:bodyPr>
           <a:lstStyle/>
           <a:p>
-            <a:pPr marL="0" indent="0" algn="l">
+            <a:pPr marL="0" indent="0" algn="ctr">
               <a:buNone/>
             </a:pPr>
             <a:r>
-              <a:rPr lang="pt-BR" sz="2000" b="0" i="0" u="none" strike="noStrike" kern="1200" cap="none" spc="0" baseline="0">
-                <a:solidFill>
-                  <a:srgbClr val="5B6178"/>
+              <a:rPr lang="pt-BR" sz="2800" b="1" i="0" u="none" strike="noStrike" kern="1200" cap="none" spc="0" baseline="0">
+                <a:solidFill>
+                  <a:srgbClr val="685BC7"/>
                 </a:solidFill>
                 <a:latin typeface="Montserrat Medium"/>
                 <a:ea typeface="Montserrat Medium"/>
                 <a:cs typeface="Montserrat Medium"/>
                 <a:sym typeface="Montserrat Medium"/>
               </a:rPr>
-              <a:t>fora da curva</a:t>
-            </a:r>
-          </a:p>
-        </p:txBody>
-      </p:sp>
-      <p:sp>
-        <p:nvSpPr>
-          <p:cNvPr id="34" name="TextBox 33"/>
+              <a:t xml:space="preserve">de 21</a:t>
+            </a:r>
+          </a:p>
+        </p:txBody>
+      </p:sp>
+      <p:sp>
+        <p:nvSpPr>
+          <p:cNvPr id="122" name="Nota"/>
           <p:cNvSpPr txBox="1"/>
           <p:nvPr/>
         </p:nvSpPr>
         <p:spPr>
           <a:xfrm>
-            <a:off x="13601700" y="7696200"/>
-            <a:ext cx="1828800" cy="1066800"/>
+            <a:off x="10561320" y="8458200"/>
+            <a:ext cx="6720840" cy="914400"/>
           </a:xfrm>
           <a:prstGeom prst="rect">
             <a:avLst/>
@@ -25960,65 +25623,25 @@
           <a:noFill/>
         </p:spPr>
         <p:txBody>
-          <a:bodyPr vert="horz" wrap="square" lIns="0" tIns="0" rIns="0" bIns="0" anchor="ctr" anchorCtr="0">
+          <a:bodyPr vert="horz" wrap="square" lIns="0" tIns="0" rIns="0" bIns="0" anchor="t" anchorCtr="0">
             <a:noAutofit/>
           </a:bodyPr>
           <a:lstStyle/>
           <a:p>
-            <a:pPr marL="0" indent="0" algn="ctr">
+            <a:pPr marL="0" indent="0" algn="l">
               <a:buNone/>
             </a:pPr>
             <a:r>
-              <a:rPr lang="pt-BR" sz="4600" b="1" i="0" u="none" strike="noStrike" kern="1200" cap="none" spc="0" baseline="0">
-                <a:solidFill>
-                  <a:srgbClr val="C8540F"/>
+              <a:rPr lang="pt-BR" sz="2800" b="0" i="0" u="none" strike="noStrike" kern="1200" cap="none" spc="0" baseline="0">
+                <a:solidFill>
+                  <a:srgbClr val="5B6178"/>
                 </a:solidFill>
                 <a:latin typeface="Montserrat Medium"/>
                 <a:ea typeface="Montserrat Medium"/>
                 <a:cs typeface="Montserrat Medium"/>
                 <a:sym typeface="Montserrat Medium"/>
               </a:rPr>
-              <a:t>10</a:t>
-            </a:r>
-          </a:p>
-        </p:txBody>
-      </p:sp>
-      <p:sp>
-        <p:nvSpPr>
-          <p:cNvPr id="35" name="TextBox 34"/>
-          <p:cNvSpPr txBox="1"/>
-          <p:nvPr/>
-        </p:nvSpPr>
-        <p:spPr>
-          <a:xfrm>
-            <a:off x="15430500" y="7696200"/>
-            <a:ext cx="1828800" cy="1066800"/>
-          </a:xfrm>
-          <a:prstGeom prst="rect">
-            <a:avLst/>
-          </a:prstGeom>
-          <a:noFill/>
-        </p:spPr>
-        <p:txBody>
-          <a:bodyPr vert="horz" wrap="square" lIns="0" tIns="0" rIns="0" bIns="0" anchor="ctr" anchorCtr="0">
-            <a:noAutofit/>
-          </a:bodyPr>
-          <a:lstStyle/>
-          <a:p>
-            <a:pPr marL="0" indent="0" algn="ctr">
-              <a:buNone/>
-            </a:pPr>
-            <a:r>
-              <a:rPr lang="pt-BR" sz="4600" b="1" i="0" u="none" strike="noStrike" kern="1200" cap="none" spc="0" baseline="0">
-                <a:solidFill>
-                  <a:srgbClr val="685BC7"/>
-                </a:solidFill>
-                <a:latin typeface="Montserrat Medium"/>
-                <a:ea typeface="Montserrat Medium"/>
-                <a:cs typeface="Montserrat Medium"/>
-                <a:sym typeface="Montserrat Medium"/>
-              </a:rPr>
-              <a:t>7</a:t>
+              <a:t xml:space="preserve">Cada ponto é um elenco da fronteira do NSGA-II</a:t>
             </a:r>
           </a:p>
         </p:txBody>
@@ -28386,8 +28009,8 @@
         </p:nvSpPr>
         <p:spPr>
           <a:xfrm>
-            <a:off x="1028700" y="3246120"/>
-            <a:ext cx="9966960" cy="5212080"/>
+            <a:off x="1028700" y="3108960"/>
+            <a:ext cx="9509760" cy="5486400"/>
           </a:xfrm>
           <a:prstGeom prst="roundRect">
             <a:avLst>
@@ -28417,8 +28040,8 @@
         </p:nvSpPr>
         <p:spPr>
           <a:xfrm>
-            <a:off x="1463040" y="3611880"/>
-            <a:ext cx="9144000" cy="365760"/>
+            <a:off x="1463040" y="3429000"/>
+            <a:ext cx="8686800" cy="457200"/>
           </a:xfrm>
           <a:prstGeom prst="rect">
             <a:avLst/>
@@ -28435,7 +28058,7 @@
               <a:buNone/>
             </a:pPr>
             <a:r>
-              <a:rPr lang="pt-BR" sz="2000" b="1" i="0" u="none" strike="noStrike" kern="1200" cap="none" spc="0" baseline="0">
+              <a:rPr lang="pt-BR" sz="2800" b="1" i="0" u="none" strike="noStrike" kern="1200" cap="none" spc="0" baseline="0">
                 <a:solidFill>
                   <a:srgbClr val="685BC7"/>
                 </a:solidFill>
@@ -28444,7 +28067,7 @@
                 <a:cs typeface="Montserrat Medium"/>
                 <a:sym typeface="Montserrat Medium"/>
               </a:rPr>
-              <a:t xml:space="preserve">O PREÇO, EM NÚMEROS</a:t>
+              <a:t xml:space="preserve">TESTES DE IDENTIDADE QUE SOBRAM</a:t>
             </a:r>
           </a:p>
         </p:txBody>
@@ -28457,8 +28080,8 @@
         </p:nvSpPr>
         <p:spPr>
           <a:xfrm>
-            <a:off x="1463040" y="4160520"/>
-            <a:ext cx="4389120" cy="1371600"/>
+            <a:off x="1463040" y="3977640"/>
+            <a:ext cx="4297680" cy="1371600"/>
           </a:xfrm>
           <a:prstGeom prst="rect">
             <a:avLst/>
@@ -28475,7 +28098,7 @@
               <a:buNone/>
             </a:pPr>
             <a:r>
-              <a:rPr lang="pt-BR" sz="9600" b="1" i="0" u="none" strike="noStrike" kern="1200" cap="none" spc="0" baseline="0">
+              <a:rPr lang="pt-BR" sz="10000" b="1" i="0" u="none" strike="noStrike" kern="1200" cap="none" spc="0" baseline="0">
                 <a:solidFill>
                   <a:srgbClr val="C8540F"/>
                 </a:solidFill>
@@ -28487,7 +28110,7 @@
               <a:t xml:space="preserve">7</a:t>
             </a:r>
             <a:r>
-              <a:rPr lang="pt-BR" sz="4000" b="1" i="0" u="none" strike="noStrike" kern="1200" cap="none" spc="0" baseline="0">
+              <a:rPr lang="pt-BR" sz="4400" b="1" i="0" u="none" strike="noStrike" kern="1200" cap="none" spc="0" baseline="0">
                 <a:solidFill>
                   <a:srgbClr val="C8540F"/>
                 </a:solidFill>
@@ -28509,8 +28132,8 @@
         </p:nvSpPr>
         <p:spPr>
           <a:xfrm>
-            <a:off x="1463040" y="5577840"/>
-            <a:ext cx="4389120" cy="822960"/>
+            <a:off x="1463040" y="5394960"/>
+            <a:ext cx="4297680" cy="457200"/>
           </a:xfrm>
           <a:prstGeom prst="rect">
             <a:avLst/>
@@ -28527,7 +28150,7 @@
               <a:buNone/>
             </a:pPr>
             <a:r>
-              <a:rPr lang="pt-BR" sz="2000" b="0" i="0" u="none" strike="noStrike" kern="1200" cap="none" spc="0" baseline="0">
+              <a:rPr lang="pt-BR" sz="2800" b="0" i="0" u="none" strike="noStrike" kern="1200" cap="none" spc="0" baseline="0">
                 <a:solidFill>
                   <a:srgbClr val="1B2740"/>
                 </a:solidFill>
@@ -28536,55 +28159,38 @@
                 <a:cs typeface="Montserrat Medium"/>
                 <a:sym typeface="Montserrat Medium"/>
               </a:rPr>
-              <a:t xml:space="preserve">testes de identidade</a:t>
-            </a:r>
-          </a:p>
+              <a:t xml:space="preserve">equilibrando tudo</a:t>
+            </a:r>
+          </a:p>
+        </p:txBody>
+      </p:sp>
+      <p:sp>
+        <p:nvSpPr>
+          <p:cNvPr id="106" name="Joelho número"/>
+          <p:cNvSpPr txBox="1"/>
+          <p:nvPr/>
+        </p:nvSpPr>
+        <p:spPr>
+          <a:xfrm>
+            <a:off x="5989320" y="3977640"/>
+            <a:ext cx="4389120" cy="1371600"/>
+          </a:xfrm>
+          <a:prstGeom prst="rect">
+            <a:avLst/>
+          </a:prstGeom>
+          <a:noFill/>
+        </p:spPr>
+        <p:txBody>
+          <a:bodyPr vert="horz" wrap="square" lIns="0" tIns="0" rIns="0" bIns="0" anchor="t" anchorCtr="0">
+            <a:noAutofit/>
+          </a:bodyPr>
+          <a:lstStyle/>
           <a:p>
             <a:pPr marL="0" indent="0" algn="l">
               <a:buNone/>
             </a:pPr>
             <a:r>
-              <a:rPr lang="pt-BR" sz="2000" b="0" i="0" u="none" strike="noStrike" kern="1200" cap="none" spc="0" baseline="0">
-                <a:solidFill>
-                  <a:srgbClr val="1B2740"/>
-                </a:solidFill>
-                <a:latin typeface="Montserrat Medium"/>
-                <a:ea typeface="Montserrat Medium"/>
-                <a:cs typeface="Montserrat Medium"/>
-                <a:sym typeface="Montserrat Medium"/>
-              </a:rPr>
-              <a:t xml:space="preserve">ao equilibrar tudo</a:t>
-            </a:r>
-          </a:p>
-        </p:txBody>
-      </p:sp>
-      <p:sp>
-        <p:nvSpPr>
-          <p:cNvPr id="106" name="Joelho número"/>
-          <p:cNvSpPr txBox="1"/>
-          <p:nvPr/>
-        </p:nvSpPr>
-        <p:spPr>
-          <a:xfrm>
-            <a:off x="6172200" y="4160520"/>
-            <a:ext cx="4480560" cy="1371600"/>
-          </a:xfrm>
-          <a:prstGeom prst="rect">
-            <a:avLst/>
-          </a:prstGeom>
-          <a:noFill/>
-        </p:spPr>
-        <p:txBody>
-          <a:bodyPr vert="horz" wrap="square" lIns="0" tIns="0" rIns="0" bIns="0" anchor="t" anchorCtr="0">
-            <a:noAutofit/>
-          </a:bodyPr>
-          <a:lstStyle/>
-          <a:p>
-            <a:pPr marL="0" indent="0" algn="l">
-              <a:buNone/>
-            </a:pPr>
-            <a:r>
-              <a:rPr lang="pt-BR" sz="9600" b="1" i="0" u="none" strike="noStrike" kern="1200" cap="none" spc="0" baseline="0">
+              <a:rPr lang="pt-BR" sz="10000" b="1" i="0" u="none" strike="noStrike" kern="1200" cap="none" spc="0" baseline="0">
                 <a:solidFill>
                   <a:srgbClr val="685BC7"/>
                 </a:solidFill>
@@ -28596,7 +28202,7 @@
               <a:t xml:space="preserve">20</a:t>
             </a:r>
             <a:r>
-              <a:rPr lang="pt-BR" sz="4000" b="1" i="0" u="none" strike="noStrike" kern="1200" cap="none" spc="0" baseline="0">
+              <a:rPr lang="pt-BR" sz="4400" b="1" i="0" u="none" strike="noStrike" kern="1200" cap="none" spc="0" baseline="0">
                 <a:solidFill>
                   <a:srgbClr val="685BC7"/>
                 </a:solidFill>
@@ -28618,8 +28224,8 @@
         </p:nvSpPr>
         <p:spPr>
           <a:xfrm>
-            <a:off x="6172200" y="5577840"/>
-            <a:ext cx="4480560" cy="822960"/>
+            <a:off x="5989320" y="5394960"/>
+            <a:ext cx="4389120" cy="457200"/>
           </a:xfrm>
           <a:prstGeom prst="rect">
             <a:avLst/>
@@ -28636,7 +28242,7 @@
               <a:buNone/>
             </a:pPr>
             <a:r>
-              <a:rPr lang="pt-BR" sz="2000" b="0" i="0" u="none" strike="noStrike" kern="1200" cap="none" spc="0" baseline="0">
+              <a:rPr lang="pt-BR" sz="2800" b="0" i="0" u="none" strike="noStrike" kern="1200" cap="none" spc="0" baseline="0">
                 <a:solidFill>
                   <a:srgbClr val="1B2740"/>
                 </a:solidFill>
@@ -28645,24 +28251,7 @@
                 <a:cs typeface="Montserrat Medium"/>
                 <a:sym typeface="Montserrat Medium"/>
               </a:rPr>
-              <a:t xml:space="preserve">no joelho, com o desbalanço</a:t>
-            </a:r>
-          </a:p>
-          <a:p>
-            <a:pPr marL="0" indent="0" algn="l">
-              <a:buNone/>
-            </a:pPr>
-            <a:r>
-              <a:rPr lang="pt-BR" sz="2000" b="0" i="0" u="none" strike="noStrike" kern="1200" cap="none" spc="0" baseline="0">
-                <a:solidFill>
-                  <a:srgbClr val="1B2740"/>
-                </a:solidFill>
-                <a:latin typeface="Montserrat Medium"/>
-                <a:ea typeface="Montserrat Medium"/>
-                <a:cs typeface="Montserrat Medium"/>
-                <a:sym typeface="Montserrat Medium"/>
-              </a:rPr>
-              <a:t xml:space="preserve">três quartos menor</a:t>
+              <a:t xml:space="preserve">no joelho da curva</a:t>
             </a:r>
           </a:p>
         </p:txBody>
@@ -28675,8 +28264,8 @@
         </p:nvCxnSpPr>
         <p:spPr>
           <a:xfrm>
-            <a:off x="1463040" y="6812280"/>
-            <a:ext cx="9098280" cy="0"/>
+            <a:off x="1463040" y="6172200"/>
+            <a:ext cx="8641080" cy="0"/>
           </a:xfrm>
           <a:prstGeom prst="line">
             <a:avLst/>
@@ -28696,8 +28285,8 @@
         </p:nvSpPr>
         <p:spPr>
           <a:xfrm>
-            <a:off x="1463040" y="6995160"/>
-            <a:ext cx="9144000" cy="777240"/>
+            <a:off x="1463040" y="6355080"/>
+            <a:ext cx="8686800" cy="914400"/>
           </a:xfrm>
           <a:prstGeom prst="rect">
             <a:avLst/>
@@ -28714,7 +28303,7 @@
               <a:buNone/>
             </a:pPr>
             <a:r>
-              <a:rPr lang="pt-BR" sz="2000" b="1" i="0" u="none" strike="noStrike" kern="1200" cap="none" spc="0" baseline="0">
+              <a:rPr lang="pt-BR" sz="2800" b="1" i="0" u="none" strike="noStrike" kern="1200" cap="none" spc="0" baseline="0">
                 <a:solidFill>
                   <a:srgbClr val="1B2740"/>
                 </a:solidFill>
@@ -28726,7 +28315,7 @@
               <a:t xml:space="preserve">Próximo passo: </a:t>
             </a:r>
             <a:r>
-              <a:rPr lang="pt-BR" sz="2000" b="0" i="0" u="none" strike="noStrike" kern="1200" cap="none" spc="0" baseline="0">
+              <a:rPr lang="pt-BR" sz="2800" b="0" i="0" u="none" strike="noStrike" kern="1200" cap="none" spc="0" baseline="0">
                 <a:solidFill>
                   <a:srgbClr val="1B2740"/>
                 </a:solidFill>
@@ -28735,7 +28324,7 @@
                 <a:cs typeface="Montserrat Medium"/>
                 <a:sym typeface="Montserrat Medium"/>
               </a:rPr>
-              <a:t xml:space="preserve">equilibrar contra um adversário que também se adapta</a:t>
+              <a:t xml:space="preserve">um adversário que também se adapta</a:t>
             </a:r>
           </a:p>
         </p:txBody>
@@ -28748,8 +28337,8 @@
         </p:nvSpPr>
         <p:spPr>
           <a:xfrm>
-            <a:off x="1463040" y="7882128"/>
-            <a:ext cx="9144000" cy="365760"/>
+            <a:off x="1463040" y="7452360"/>
+            <a:ext cx="8686800" cy="457200"/>
           </a:xfrm>
           <a:prstGeom prst="rect">
             <a:avLst/>
@@ -28766,7 +28355,7 @@
               <a:buNone/>
             </a:pPr>
             <a:r>
-              <a:rPr lang="pt-BR" sz="1800" b="0" i="0" u="none" strike="noStrike" kern="1200" cap="none" spc="0" baseline="0">
+              <a:rPr lang="pt-BR" sz="2800" b="0" i="0" u="none" strike="noStrike" kern="1200" cap="none" spc="0" baseline="0">
                 <a:solidFill>
                   <a:srgbClr val="5B6178"/>
                 </a:solidFill>
@@ -28775,7 +28364,7 @@
                 <a:cs typeface="Montserrat Medium"/>
                 <a:sym typeface="Montserrat Medium"/>
               </a:rPr>
-              <a:t xml:space="preserve">Resultado preliminar · modelo simplificado · cinco arquétipos</a:t>
+              <a:t xml:space="preserve">Resultado preliminar, num modelo simplificado</a:t>
             </a:r>
           </a:p>
         </p:txBody>
@@ -28788,8 +28377,8 @@
         </p:nvSpPr>
         <p:spPr>
           <a:xfrm>
-            <a:off x="11430000" y="3246120"/>
-            <a:ext cx="5829300" cy="5212080"/>
+            <a:off x="10927080" y="3108960"/>
+            <a:ext cx="6332220" cy="5486400"/>
           </a:xfrm>
           <a:prstGeom prst="roundRect">
             <a:avLst>
@@ -28819,8 +28408,8 @@
         </p:nvSpPr>
         <p:spPr>
           <a:xfrm>
-            <a:off x="11841480" y="3611880"/>
-            <a:ext cx="5029200" cy="457200"/>
+            <a:off x="11247120" y="3429000"/>
+            <a:ext cx="5692140" cy="548640"/>
           </a:xfrm>
           <a:prstGeom prst="rect">
             <a:avLst/>
@@ -28833,11 +28422,11 @@
           </a:bodyPr>
           <a:lstStyle/>
           <a:p>
-            <a:pPr marL="0" indent="0" algn="l">
+            <a:pPr marL="0" indent="0" algn="ctr">
               <a:buNone/>
             </a:pPr>
             <a:r>
-              <a:rPr lang="pt-BR" sz="2600" b="1" i="0" u="none" strike="noStrike" kern="1200" cap="none" spc="0" baseline="0">
+              <a:rPr lang="pt-BR" sz="3200" b="1" i="0" u="none" strike="noStrike" kern="1200" cap="none" spc="0" baseline="0">
                 <a:solidFill>
                   <a:srgbClr val="FFFFFF"/>
                 </a:solidFill>
@@ -28859,8 +28448,8 @@
         </p:nvSpPr>
         <p:spPr>
           <a:xfrm>
-            <a:off x="12687300" y="4297680"/>
-            <a:ext cx="3314700" cy="3314700"/>
+            <a:off x="12673584" y="4160520"/>
+            <a:ext cx="2834640" cy="2834640"/>
           </a:xfrm>
           <a:prstGeom prst="roundRect">
             <a:avLst>
@@ -28898,8 +28487,8 @@
         </p:blipFill>
         <p:spPr>
           <a:xfrm>
-            <a:off x="12801600" y="4411980"/>
-            <a:ext cx="3086100" cy="3086100"/>
+            <a:off x="12765024" y="4251960"/>
+            <a:ext cx="2651760" cy="2651760"/>
           </a:xfrm>
           <a:prstGeom prst="rect">
             <a:avLst/>
@@ -28914,8 +28503,8 @@
         </p:nvSpPr>
         <p:spPr>
           <a:xfrm>
-            <a:off x="11841480" y="7818120"/>
-            <a:ext cx="5029200" cy="365760"/>
+            <a:off x="11247120" y="7223760"/>
+            <a:ext cx="5692140" cy="960120"/>
           </a:xfrm>
           <a:prstGeom prst="rect">
             <a:avLst/>
@@ -28932,7 +28521,7 @@
               <a:buNone/>
             </a:pPr>
             <a:r>
-              <a:rPr lang="pt-BR" sz="1700" b="1" i="0" u="none" strike="noStrike" kern="1200" cap="none" spc="0" baseline="0">
+              <a:rPr lang="pt-BR" sz="2800" b="1" i="0" u="none" strike="noStrike" kern="1200" cap="none" spc="0" baseline="0">
                 <a:solidFill>
                   <a:srgbClr val="BDB6EC"/>
                 </a:solidFill>
@@ -28941,7 +28530,24 @@
                 <a:cs typeface="Montserrat Medium"/>
                 <a:sym typeface="Montserrat Medium"/>
               </a:rPr>
-              <a:t xml:space="preserve">github.com/M-Gimenes/Simulation</a:t>
+              <a:t xml:space="preserve">github.com/</a:t>
+            </a:r>
+          </a:p>
+          <a:p>
+            <a:pPr marL="0" indent="0" algn="ctr">
+              <a:buNone/>
+            </a:pPr>
+            <a:r>
+              <a:rPr lang="pt-BR" sz="2800" b="1" i="0" u="none" strike="noStrike" kern="1200" cap="none" spc="0" baseline="0">
+                <a:solidFill>
+                  <a:srgbClr val="BDB6EC"/>
+                </a:solidFill>
+                <a:latin typeface="Montserrat Medium"/>
+                <a:ea typeface="Montserrat Medium"/>
+                <a:cs typeface="Montserrat Medium"/>
+                <a:sym typeface="Montserrat Medium"/>
+              </a:rPr>
+              <a:t xml:space="preserve">M-Gimenes/Simulation</a:t>
             </a:r>
           </a:p>
         </p:txBody>
@@ -30230,7 +29836,7 @@
         </p:nvSpPr>
         <p:spPr>
           <a:xfrm>
-            <a:off x="6456166" y="2004867"/>
+            <a:off x="6456166" y="1417320"/>
             <a:ext cx="5375675" cy="895353"/>
           </a:xfrm>
           <a:prstGeom prst="rect">
@@ -30283,10 +29889,10 @@
       </p:sp>
       <p:sp>
         <p:nvSpPr>
-          <p:cNvPr id="14" name="TextBox 14">
+          <p:cNvPr id="15" name="TextBox 15">
             <a:extLst>
               <a:ext uri="{FF2B5EF4-FFF2-40B4-BE49-F238E27FC236}">
-                <a16:creationId xmlns:a16="http://schemas.microsoft.com/office/drawing/2014/main" id="{B5586D80-CBCE-DABC-14B5-DBB0DA8D3DE5}"/>
+                <a16:creationId xmlns:a16="http://schemas.microsoft.com/office/drawing/2014/main" id="{85DFF21E-6EAC-1F0A-B612-E00C67714EE6}"/>
               </a:ext>
             </a:extLst>
           </p:cNvPr>
@@ -30295,8 +29901,8 @@
         </p:nvSpPr>
         <p:spPr>
           <a:xfrm>
-            <a:off x="6456166" y="3172007"/>
-            <a:ext cx="5375675" cy="381003"/>
+            <a:off x="4572000" y="2697480"/>
+            <a:ext cx="9144000" cy="457200"/>
           </a:xfrm>
           <a:prstGeom prst="rect">
             <a:avLst/>
@@ -30324,7 +29930,7 @@
               </a:spcAft>
               <a:buNone/>
               <a:tabLst/>
-              <a:defRPr sz="1800" b="0" i="0" u="none" strike="noStrike" kern="0" cap="none" spc="0" baseline="0">
+              <a:defRPr sz="2800" b="0" i="0" u="none" strike="noStrike" kern="0" cap="none" spc="0" baseline="0">
                 <a:solidFill>
                   <a:srgbClr val="000000"/>
                 </a:solidFill>
@@ -30332,72 +29938,7 @@
               </a:defRPr>
             </a:pPr>
             <a:r>
-              <a:rPr lang="en-US" sz="2500" b="0" i="1" u="none" strike="noStrike" kern="1200" cap="none" spc="0" baseline="0">
-                <a:solidFill>
-                  <a:srgbClr val="685BC7"/>
-                </a:solidFill>
-                <a:uFillTx/>
-                <a:latin typeface="Montserrat Italics"/>
-                <a:ea typeface="Montserrat Italics"/>
-                <a:cs typeface="Montserrat Italics"/>
-              </a:rPr>
-              <a:t>Contato:</a:t>
-            </a:r>
-          </a:p>
-        </p:txBody>
-      </p:sp>
-      <p:sp>
-        <p:nvSpPr>
-          <p:cNvPr id="15" name="TextBox 15">
-            <a:extLst>
-              <a:ext uri="{FF2B5EF4-FFF2-40B4-BE49-F238E27FC236}">
-                <a16:creationId xmlns:a16="http://schemas.microsoft.com/office/drawing/2014/main" id="{85DFF21E-6EAC-1F0A-B612-E00C67714EE6}"/>
-              </a:ext>
-            </a:extLst>
-          </p:cNvPr>
-          <p:cNvSpPr txBox="1"/>
-          <p:nvPr/>
-        </p:nvSpPr>
-        <p:spPr>
-          <a:xfrm>
-            <a:off x="4572000" y="3788898"/>
-            <a:ext cx="9144000" cy="381003"/>
-          </a:xfrm>
-          <a:prstGeom prst="rect">
-            <a:avLst/>
-          </a:prstGeom>
-          <a:noFill/>
-          <a:ln cap="flat">
-            <a:noFill/>
-          </a:ln>
-        </p:spPr>
-        <p:txBody>
-          <a:bodyPr vert="horz" wrap="square" lIns="0" tIns="0" rIns="0" bIns="0" anchor="t" anchorCtr="1" compatLnSpc="1">
-            <a:spAutoFit/>
-          </a:bodyPr>
-          <a:lstStyle/>
-          <a:p>
-            <a:pPr marL="0" marR="0" lvl="0" indent="0" algn="ctr" defTabSz="914400" rtl="0" fontAlgn="auto" hangingPunct="1">
-              <a:lnSpc>
-                <a:spcPts val="3000"/>
-              </a:lnSpc>
-              <a:spcBef>
-                <a:spcPts val="0"/>
-              </a:spcBef>
-              <a:spcAft>
-                <a:spcPts val="0"/>
-              </a:spcAft>
-              <a:buNone/>
-              <a:tabLst/>
-              <a:defRPr sz="1800" b="0" i="0" u="none" strike="noStrike" kern="0" cap="none" spc="0" baseline="0">
-                <a:solidFill>
-                  <a:srgbClr val="000000"/>
-                </a:solidFill>
-                <a:uFillTx/>
-              </a:defRPr>
-            </a:pPr>
-            <a:r>
-              <a:rPr lang="en-US" sz="2500" b="1" i="0" u="none" strike="noStrike" kern="1200" cap="none" spc="0" baseline="0">
+              <a:rPr lang="en-US" sz="2800" b="1" i="0" u="none" strike="noStrike" kern="1200" cap="none" spc="0" baseline="0">
                 <a:solidFill>
                   <a:srgbClr val="685BC7"/>
                 </a:solidFill>
@@ -30419,8 +29960,8 @@
         </p:nvSpPr>
         <p:spPr>
           <a:xfrm>
-            <a:off x="4572000" y="4315968"/>
-            <a:ext cx="9144000" cy="384048"/>
+            <a:off x="4572000" y="3246120"/>
+            <a:ext cx="9144000" cy="457200"/>
           </a:xfrm>
           <a:prstGeom prst="rect">
             <a:avLst/>
@@ -30437,7 +29978,7 @@
               <a:buNone/>
             </a:pPr>
             <a:r>
-              <a:rPr lang="pt-BR" sz="1800" b="1" i="0" u="none" strike="noStrike" kern="1200" cap="none" spc="0" baseline="0">
+              <a:rPr lang="pt-BR" sz="2800" b="1" i="0" u="none" strike="noStrike" kern="1200" cap="none" spc="0" baseline="0">
                 <a:solidFill>
                   <a:srgbClr val="685BC7"/>
                 </a:solidFill>
@@ -30459,8 +30000,8 @@
         </p:nvSpPr>
         <p:spPr>
           <a:xfrm>
-            <a:off x="8321040" y="4846320"/>
-            <a:ext cx="1645920" cy="1645920"/>
+            <a:off x="7818120" y="3840480"/>
+            <a:ext cx="2651760" cy="2651760"/>
           </a:xfrm>
           <a:prstGeom prst="roundRect">
             <a:avLst>
@@ -30498,8 +30039,8 @@
         </p:blipFill>
         <p:spPr>
           <a:xfrm>
-            <a:off x="8366760" y="4892040"/>
-            <a:ext cx="1554480" cy="1554480"/>
+            <a:off x="7863840" y="3886200"/>
+            <a:ext cx="2560320" cy="2560320"/>
           </a:xfrm>
           <a:prstGeom prst="rect">
             <a:avLst/>

</xml_diff>

<commit_message>
talk: contribuição explícita, exemplo de teste e fecho na mensagem
- slide 5 diz a contribuição e nomeia desbalanço e desvio
- slide 6 dá um exemplo de teste de identidade
- joelho definido na fala; conclusão termina na resposta
- pergunta provável: por que algoritmo genético

Co-Authored-By: Claude Opus 5.5 <noreply@anthropic.com>
Claude-Session: https://claude.ai/code/session_01DFzhQx16GXrgQs3QusNGF8
</commit_message>
<xml_diff>
--- a/overleaf/talk-latinoware-2026/slides.pptx
+++ b/overleaf/talk-latinoware-2026/slides.pptx
@@ -797,7 +797,7 @@
           <a:lstStyle/>
           <a:p>
             <a:r>
-              <a:t>Existem duas formas de comprometer um jogo competitivo. A primeira é a mais conhecida: um personagem fica forte demais, e todos os jogadores passam a escolhê-lo. A segunda é mais sutil. Para corrigir a primeira, ajustam-se os números até que ninguém domine. Só que, nesse processo, os personagens podem perder justamente aquilo que os tornava únicos. O jogo fica equilibrado, mas a escolha do personagem deixa de importar. O desafio, portanto, é equilibrar preservando a diferença.</a:t>
+              <a:t>Existem duas formas de comprometer um jogo competitivo. A primeira é a mais conhecida: um personagem fica forte demais, e todos os jogadores passam a escolhê-lo. A segunda é mais sutil. Para corrigir a primeira, os números são ajustados até que ninguém domine. Só que, nesse processo, os personagens podem perder justamente aquilo que os tornava únicos. O jogo fica equilibrado, mas a escolha do personagem deixa de importar. O desafio, portanto, é equilibrar preservando a diferença.</a:t>
             </a:r>
           </a:p>
         </p:txBody>
@@ -867,7 +867,7 @@
           <a:lstStyle/>
           <a:p>
             <a:r>
-              <a:t>Para o algoritmo genético, cada indivíduo é um elenco inteiro, e não um personagem, porque o equilíbrio é uma propriedade do conjunto. São cinco personagens com dez genes cada: atributos como vida, dano, alcance e velocidade, e pesos que indicam o quanto cada um prefere avançar, recuar ou se defender. A população tem trezentos elencos: o original e outros sorteados. A cada geração, um simulador coloca os personagens de cada elenco para lutar todos contra todos, cento e cinquenta vezes por confronto. Os melhores elencos são selecionados e cruzados, trocando personagens inteiros entre si, e sofrem mutações. O processo se repete por até cento e cinquenta gerações.</a:t>
+              <a:t>Para o algoritmo genético, cada indivíduo é um elenco inteiro, e não um personagem, porque o equilíbrio é uma propriedade do conjunto. São cinco personagens com dez genes cada, entre atributos de combate e pesos de comportamento. A população tem trezentos elencos: o original e outros sorteados. A cada geração, um simulador coloca os personagens de cada elenco para lutar todos contra todos, cento e cinquenta vezes por confronto. Os melhores elencos são selecionados e cruzados, trocando personagens inteiros entre si, e sofrem mutações.</a:t>
             </a:r>
           </a:p>
         </p:txBody>
@@ -1147,7 +1147,7 @@
           <a:lstStyle/>
           <a:p>
             <a:r>
-              <a:t>A decisão central do trabalho é esta: não obrigamos o algoritmo a preservar os personagens. Ele busca apenas duas coisas: equilíbrio e proximidade com o elenco original. Afastar-se do original tem um custo, mas é permitido. Quem deveria vencer quem nunca entra na busca; isso só é medido depois. Se a identidade fosse uma regra, ela sobreviveria por obrigação. Medida por fora, sua preservação passa a ser um resultado.</a:t>
+              <a:t>A maior parte dos trabalhos de balanceamento por busca otimiza apenas o equilíbrio. Aqui, a identidade entra como um segundo objetivo, explícito. E a decisão central é esta: não obrigamos o algoritmo a preservar os personagens. Ele busca duas coisas: equilíbrio, medido pelo desbalanço, e proximidade com o elenco original, medida pelo desvio. Quem deveria vencer quem nunca entra na busca; isso só é medido depois. Se a identidade fosse uma regra, ela sobreviveria por obrigação. Como ela é medida por fora, a preservação passa a ser um resultado.</a:t>
             </a:r>
           </a:p>
         </p:txBody>
@@ -1287,7 +1287,7 @@
           <a:lstStyle/>
           <a:p>
             <a:r>
-              <a:t>O ponto de partida é o elenco original, que chamamos de canônico. Ele passa nos vinte e um testes que escrevemos para verificar a identidade de cada personagem, mas nenhum dos dez confrontos é equilibrado: um personagem vence todas as lutas, e outro não vence nenhuma.</a:t>
+              <a:t>O ponto de partida é o elenco original, que chamamos de canônico. Ele passa nos vinte e um testes que escrevemos para verificar a identidade dos personagens, como o rushdown ser o mais rápido e o turtle ter mais vida. Mas nenhum dos dez confrontos é equilibrado: um personagem vence todas as lutas, e outro não vence nenhuma.</a:t>
             </a:r>
           </a:p>
           <a:p>
@@ -1362,7 +1362,7 @@
           <a:lstStyle/>
           <a:p>
             <a:r>
-              <a:t>Cada ponto deste gráfico é um elenco. Para a esquerda, mais equilíbrio; para baixo, mais identidade. O canto inferior esquerdo está vazio: para ganhar de um lado, é preciso perder do outro. No joelho da curva, o desbalanço já caiu três quartos do caminho, enquanto vinte dos vinte e um testes continuam valendo. Quem projeta o jogo pode, então, escolher onde parar, conhecendo o custo de cada passo.</a:t>
+              <a:t>Cada ponto deste gráfico é um elenco. Para a esquerda, mais equilíbrio; para baixo, mais identidade. O canto inferior esquerdo está vazio: para ganhar de um lado, é preciso perder do outro. No joelho da curva, o ponto em que ela muda de inclinação, o desbalanço já caiu três quartos do caminho, enquanto vinte dos vinte e um testes continuam valendo.</a:t>
             </a:r>
           </a:p>
         </p:txBody>
@@ -1502,12 +1502,12 @@
           <a:lstStyle/>
           <a:p>
             <a:r>
-              <a:t>A resposta, ainda preliminar, é sim: é possível equilibrar sem apagar as identidades, mas não sem custo, e esse custo agora pode ser medido. O modelo ainda é simplificado, e o próximo passo é testar o equilíbrio contra um adversário que também se adapta.</a:t>
+              <a:t>O modelo ainda é simplificado, e o próximo passo é testar o equilíbrio contra um adversário que também se adapta. O código é aberto, segue em desenvolvimento e está disponível no GitHub, pelo QR code, para quem quiser testá-lo.</a:t>
             </a:r>
           </a:p>
           <a:p>
             <a:r>
-              <a:t>O código é aberto e está disponível no GitHub, pelo QR code, para quem quiser testá-lo. O projeto segue em desenvolvimento e recebendo atualizações. Obrigado.</a:t>
+              <a:t>Para concluir: a resposta, ainda preliminar, é sim. É possível equilibrar sem apagar as identidades, mas não sem custo, e esse custo agora pode ser medido. Obrigado.</a:t>
             </a:r>
           </a:p>
         </p:txBody>
@@ -24528,16 +24528,28 @@
               <a:buNone/>
             </a:pPr>
             <a:r>
-              <a:rPr lang="pt-BR" sz="2800" b="0" i="0" u="none" strike="noStrike" kern="1200" cap="none" spc="0" baseline="0">
-                <a:solidFill>
-                  <a:srgbClr val="1B2740"/>
+              <a:rPr lang="pt-BR" sz="2800" b="1" i="0" u="none" strike="noStrike" kern="1200" cap="none" spc="0" baseline="0">
+                <a:solidFill>
+                  <a:srgbClr val="C8540F"/>
                 </a:solidFill>
                 <a:latin typeface="Montserrat Medium"/>
                 <a:ea typeface="Montserrat Medium"/>
                 <a:cs typeface="Montserrat Medium"/>
                 <a:sym typeface="Montserrat Medium"/>
               </a:rPr>
-              <a:t xml:space="preserve">nenhum personagem domina</a:t>
+              <a:t xml:space="preserve">desbalanço: </a:t>
+            </a:r>
+            <a:r>
+              <a:rPr lang="pt-BR" sz="2800" b="0" i="0" u="none" strike="noStrike" kern="1200" cap="none" spc="0" baseline="0">
+                <a:solidFill>
+                  <a:srgbClr val="1B2740"/>
+                </a:solidFill>
+                <a:latin typeface="Montserrat Medium"/>
+                <a:ea typeface="Montserrat Medium"/>
+                <a:cs typeface="Montserrat Medium"/>
+                <a:sym typeface="Montserrat Medium"/>
+              </a:rPr>
+              <a:t xml:space="preserve">ninguém domina</a:t>
             </a:r>
           </a:p>
         </p:txBody>
@@ -24639,16 +24651,28 @@
               <a:buNone/>
             </a:pPr>
             <a:r>
-              <a:rPr lang="pt-BR" sz="2800" b="0" i="0" u="none" strike="noStrike" kern="1200" cap="none" spc="0" baseline="0">
-                <a:solidFill>
-                  <a:srgbClr val="1B2740"/>
+              <a:rPr lang="pt-BR" sz="2800" b="1" i="0" u="none" strike="noStrike" kern="1200" cap="none" spc="0" baseline="0">
+                <a:solidFill>
+                  <a:srgbClr val="685BC7"/>
                 </a:solidFill>
                 <a:latin typeface="Montserrat Medium"/>
                 <a:ea typeface="Montserrat Medium"/>
                 <a:cs typeface="Montserrat Medium"/>
                 <a:sym typeface="Montserrat Medium"/>
               </a:rPr>
-              <a:t xml:space="preserve">afastar-se tem custo, mas é permitido</a:t>
+              <a:t xml:space="preserve">desvio: </a:t>
+            </a:r>
+            <a:r>
+              <a:rPr lang="pt-BR" sz="2800" b="0" i="0" u="none" strike="noStrike" kern="1200" cap="none" spc="0" baseline="0">
+                <a:solidFill>
+                  <a:srgbClr val="1B2740"/>
+                </a:solidFill>
+                <a:latin typeface="Montserrat Medium"/>
+                <a:ea typeface="Montserrat Medium"/>
+                <a:cs typeface="Montserrat Medium"/>
+                <a:sym typeface="Montserrat Medium"/>
+              </a:rPr>
+              <a:t xml:space="preserve">afastar-se custa, mas pode</a:t>
             </a:r>
           </a:p>
         </p:txBody>
@@ -28820,8 +28844,8 @@
         </p:nvSpPr>
         <p:spPr>
           <a:xfrm>
-            <a:off x="1028700" y="8138160"/>
-            <a:ext cx="16230600" cy="502920"/>
+            <a:off x="1028700" y="8092440"/>
+            <a:ext cx="16230600" cy="457200"/>
           </a:xfrm>
           <a:prstGeom prst="rect">
             <a:avLst/>
@@ -28848,6 +28872,46 @@
                 <a:sym typeface="Montserrat Medium"/>
               </a:rPr>
               <a:t xml:space="preserve">Confronto equilibrado: taxa de vitória entre 40% e 60%</a:t>
+            </a:r>
+          </a:p>
+        </p:txBody>
+      </p:sp>
+      <p:sp>
+        <p:nvSpPr>
+          <p:cNvPr id="118" name="Nota teste"/>
+          <p:cNvSpPr txBox="1"/>
+          <p:nvPr/>
+        </p:nvSpPr>
+        <p:spPr>
+          <a:xfrm>
+            <a:off x="1028700" y="8641080"/>
+            <a:ext cx="16230600" cy="457200"/>
+          </a:xfrm>
+          <a:prstGeom prst="rect">
+            <a:avLst/>
+          </a:prstGeom>
+          <a:noFill/>
+        </p:spPr>
+        <p:txBody>
+          <a:bodyPr vert="horz" wrap="square" lIns="0" tIns="0" rIns="0" bIns="0" anchor="t" anchorCtr="0">
+            <a:noAutofit/>
+          </a:bodyPr>
+          <a:lstStyle/>
+          <a:p>
+            <a:pPr marL="0" indent="0" algn="l">
+              <a:buNone/>
+            </a:pPr>
+            <a:r>
+              <a:rPr lang="pt-BR" sz="2800" b="0" i="0" u="none" strike="noStrike" kern="1200" cap="none" spc="0" baseline="0">
+                <a:solidFill>
+                  <a:srgbClr val="5B6178"/>
+                </a:solidFill>
+                <a:latin typeface="Montserrat Medium"/>
+                <a:ea typeface="Montserrat Medium"/>
+                <a:cs typeface="Montserrat Medium"/>
+                <a:sym typeface="Montserrat Medium"/>
+              </a:rPr>
+              <a:t xml:space="preserve">Teste de identidade: por exemplo, o rushdown ser o mais rápido</a:t>
             </a:r>
           </a:p>
         </p:txBody>

</xml_diff>

<commit_message>
talk: reescreve a abertura e o próximo passo
- slide 2: duas formas de errar no balanceamento, com a segunda nascendo da correção da primeira
- conclusão: próximo passo é modelar o combate com mais variáveis

Co-Authored-By: Claude Opus 5.5 <noreply@anthropic.com>
Claude-Session: https://claude.ai/code/session_01DFzhQx16GXrgQs3QusNGF8
</commit_message>
<xml_diff>
--- a/overleaf/talk-latinoware-2026/slides.pptx
+++ b/overleaf/talk-latinoware-2026/slides.pptx
@@ -798,7 +798,7 @@
           <a:lstStyle/>
           <a:p>
             <a:r>
-              <a:t>Existem duas formas de comprometer um jogo competitivo. A primeira é a mais conhecida: um personagem fica forte demais, e todos passam a escolhê-lo. A segunda é mais sutil. Para corrigir a primeira, os números são ajustados até que ninguém domine, e, nesse processo, os personagens podem perder aquilo que os tornava únicos. O jogo fica equilibrado, mas a escolha do personagem deixa de importar. O desafio, portanto, é equilibrar preservando a diferença.</a:t>
+              <a:t>Existem duas formas de errar no balanceamento de um jogo competitivo. A mais conhecida é deixar um personagem forte demais: todos passam a escolhê-lo. A outra é mais sutil e costuma aparecer justamente ao corrigir a primeira. Os números são ajustados até que ninguém domine, mas, no caminho, os personagens ficam parecidos e perdem o que os tornava únicos. O jogo fica equilibrado, mas a escolha do personagem deixa de importar. O desafio, portanto, é equilibrar preservando a diferença.</a:t>
             </a:r>
           </a:p>
         </p:txBody>
@@ -1583,7 +1583,7 @@
           <a:lstStyle/>
           <a:p>
             <a:r>
-              <a:t>O modelo ainda é simplificado, e o próximo passo é testar o equilíbrio contra um adversário que também se adapta. O código é aberto, segue em desenvolvimento e está disponível no GitHub, pelo QR code, para quem quiser testá-lo.</a:t>
+              <a:t>O modelo ainda é simplificado, e o próximo passo é aperfeiçoar a modelagem do ambiente de combate, incluindo mais variáveis no sistema, como os tempos de início e de recuperação dos golpes. O código é aberto, segue em desenvolvimento e está disponível no GitHub, pelo QR code, para quem quiser testá-lo.</a:t>
             </a:r>
           </a:p>
           <a:p>
@@ -14005,7 +14005,7 @@
                 <a:cs typeface="Montserrat Medium"/>
                 <a:sym typeface="Montserrat Medium"/>
               </a:rPr>
-              <a:t xml:space="preserve">Duas formas de comprometer um jogo competitivo</a:t>
+              <a:t xml:space="preserve">Duas formas de errar no balanceamento</a:t>
             </a:r>
           </a:p>
         </p:txBody>
@@ -35829,7 +35829,7 @@
                 <a:cs typeface="Montserrat Medium"/>
                 <a:sym typeface="Montserrat Medium"/>
               </a:rPr>
-              <a:t xml:space="preserve">um adversário que também se adapta</a:t>
+              <a:t xml:space="preserve">modelar o combate com mais variáveis</a:t>
             </a:r>
           </a:p>
         </p:txBody>

</xml_diff>